<commit_message>
vault backup: 2026-05-09 18:19:16
</commit_message>
<xml_diff>
--- a/01_Courses/01_Active/00_BSKT/00_Kinh Te Vi Mo/07_AI-Workspace/Outputs/Xe-dien-Alpha-Trinh-bay.pptx
+++ b/01_Courses/01_Active/00_BSKT/00_Kinh Te Vi Mo/07_AI-Workspace/Outputs/Xe-dien-Alpha-Trinh-bay.pptx
@@ -3121,8 +3121,8 @@
         </p:nvSpPr>
         <p:spPr>
           <a:xfrm>
-            <a:off x="720000" y="2160000"/>
-            <a:ext cx="7560000" cy="1440000"/>
+            <a:off x="720000" y="1980000"/>
+            <a:ext cx="7560000" cy="1800000"/>
           </a:xfrm>
           <a:prstGeom prst="rect">
             <a:avLst/>
@@ -3136,7 +3136,7 @@
           <a:lstStyle/>
           <a:p>
             <a:pPr algn="ctr">
-              <a:defRPr sz="3600" b="1">
+              <a:defRPr sz="3400" b="1">
                 <a:solidFill>
                   <a:srgbClr val="FFFFFF"/>
                 </a:solidFill>
@@ -3148,9 +3148,9 @@
           </a:p>
           <a:p>
             <a:pPr algn="ctr">
-              <a:defRPr sz="1800">
-                <a:solidFill>
-                  <a:srgbClr val="CCCCCC"/>
+              <a:defRPr sz="1600">
+                <a:solidFill>
+                  <a:srgbClr val="BBBBBB"/>
                 </a:solidFill>
               </a:defRPr>
             </a:pPr>
@@ -3194,8 +3194,8 @@
         </p:nvSpPr>
         <p:spPr>
           <a:xfrm>
-            <a:off x="720000" y="2520000"/>
-            <a:ext cx="7560000" cy="1080000"/>
+            <a:off x="720000" y="2340000"/>
+            <a:ext cx="7560000" cy="1440000"/>
           </a:xfrm>
           <a:prstGeom prst="rect">
             <a:avLst/>
@@ -3209,14 +3209,26 @@
           <a:lstStyle/>
           <a:p>
             <a:pPr algn="ctr">
-              <a:defRPr sz="3200" b="1">
+              <a:defRPr sz="3000" b="1">
                 <a:solidFill>
                   <a:srgbClr val="FFFFFF"/>
                 </a:solidFill>
               </a:defRPr>
             </a:pPr>
             <a:r>
-              <a:t>BÀI TOÁN CỦA ECODRIVE</a:t>
+              <a:t>QUYẾT ĐỊNH CỦA ECODRIVE</a:t>
+            </a:r>
+          </a:p>
+          <a:p>
+            <a:pPr algn="ctr">
+              <a:defRPr sz="1400">
+                <a:solidFill>
+                  <a:srgbClr val="CCCCCC"/>
+                </a:solidFill>
+              </a:defRPr>
+            </a:pPr>
+            <a:r>
+              <a:t>Trả lời câu hỏi 3</a:t>
             </a:r>
           </a:p>
         </p:txBody>
@@ -3247,8 +3259,8 @@
         </p:nvSpPr>
         <p:spPr>
           <a:xfrm>
-            <a:off x="540000" y="288000"/>
-            <a:ext cx="7920000" cy="792000"/>
+            <a:off x="540000" y="216000"/>
+            <a:ext cx="7920000" cy="720000"/>
           </a:xfrm>
           <a:prstGeom prst="rect">
             <a:avLst/>
@@ -3262,14 +3274,26 @@
           <a:lstStyle/>
           <a:p>
             <a:pPr>
-              <a:defRPr sz="2600" b="1">
+              <a:defRPr sz="2400" b="1">
                 <a:solidFill>
                   <a:srgbClr val="1B1B2F"/>
                 </a:solidFill>
               </a:defRPr>
             </a:pPr>
             <a:r>
-              <a:t>KHI CHI PHÍ ĐẦU VÀO TĂNG</a:t>
+              <a:t>LITHIUM TĂNG → ĐIỀU CHỈNH GIÁ VÀ SẢN LƯỢNG</a:t>
+            </a:r>
+          </a:p>
+          <a:p>
+            <a:pPr>
+              <a:defRPr sz="1200" i="1">
+                <a:solidFill>
+                  <a:srgbClr val="2D6A4F"/>
+                </a:solidFill>
+              </a:defRPr>
+            </a:pPr>
+            <a:r>
+              <a:t>Câu 3: Với vai trò GĐ sản xuất, quyết định giá và sản lượng như thế nào?</a:t>
             </a:r>
           </a:p>
         </p:txBody>
@@ -3282,8 +3306,8 @@
         </p:nvSpPr>
         <p:spPr>
           <a:xfrm>
-            <a:off x="648000" y="1152000"/>
-            <a:ext cx="7560000" cy="5040000"/>
+            <a:off x="648000" y="1080000"/>
+            <a:ext cx="7560000" cy="5220000"/>
           </a:xfrm>
           <a:prstGeom prst="rect">
             <a:avLst/>
@@ -3298,68 +3322,68 @@
           <a:p>
             <a:pPr>
               <a:spcAft>
-                <a:spcPts val="600"/>
-              </a:spcAft>
-              <a:defRPr sz="1700">
-                <a:solidFill>
-                  <a:srgbClr val="555555"/>
-                </a:solidFill>
-              </a:defRPr>
-            </a:pPr>
-            <a:r>
-              <a:t>EcoDrive nắm 60% thị phần nhờ lợi thế quy mô</a:t>
-            </a:r>
-          </a:p>
-          <a:p>
-            <a:pPr>
-              <a:spcAft>
-                <a:spcPts val="600"/>
-              </a:spcAft>
-              <a:defRPr sz="1700">
-                <a:solidFill>
-                  <a:srgbClr val="555555"/>
-                </a:solidFill>
-              </a:defRPr>
-            </a:pPr>
-          </a:p>
-          <a:p>
-            <a:pPr>
-              <a:spcAft>
-                <a:spcPts val="600"/>
-              </a:spcAft>
-              <a:defRPr sz="1700">
-                <a:solidFill>
-                  <a:srgbClr val="555555"/>
-                </a:solidFill>
-              </a:defRPr>
-            </a:pPr>
-            <a:r>
-              <a:t>Lithium tăng giá:</a:t>
-            </a:r>
-          </a:p>
-          <a:p>
-            <a:pPr>
-              <a:spcAft>
-                <a:spcPts val="600"/>
-              </a:spcAft>
-              <a:defRPr sz="1700">
-                <a:solidFill>
-                  <a:srgbClr val="555555"/>
-                </a:solidFill>
-              </a:defRPr>
-            </a:pPr>
-            <a:r>
-              <a:t>   Chi phí biên (MC) dịch lên</a:t>
-            </a:r>
-          </a:p>
-          <a:p>
-            <a:pPr>
-              <a:spcAft>
-                <a:spcPts val="600"/>
-              </a:spcAft>
-              <a:defRPr sz="1700">
-                <a:solidFill>
-                  <a:srgbClr val="555555"/>
+                <a:spcPts val="500"/>
+              </a:spcAft>
+              <a:defRPr sz="1600">
+                <a:solidFill>
+                  <a:srgbClr val="444444"/>
+                </a:solidFill>
+              </a:defRPr>
+            </a:pPr>
+            <a:r>
+              <a:t>EcoDrive 60% thị phần nhờ lợi thế quy mô</a:t>
+            </a:r>
+          </a:p>
+          <a:p>
+            <a:pPr>
+              <a:spcAft>
+                <a:spcPts val="500"/>
+              </a:spcAft>
+              <a:defRPr sz="1600">
+                <a:solidFill>
+                  <a:srgbClr val="444444"/>
+                </a:solidFill>
+              </a:defRPr>
+            </a:pPr>
+          </a:p>
+          <a:p>
+            <a:pPr>
+              <a:spcAft>
+                <a:spcPts val="500"/>
+              </a:spcAft>
+              <a:defRPr sz="1600">
+                <a:solidFill>
+                  <a:srgbClr val="444444"/>
+                </a:solidFill>
+              </a:defRPr>
+            </a:pPr>
+            <a:r>
+              <a:t>Khi Lithium tăng giá:</a:t>
+            </a:r>
+          </a:p>
+          <a:p>
+            <a:pPr>
+              <a:spcAft>
+                <a:spcPts val="500"/>
+              </a:spcAft>
+              <a:defRPr sz="1600">
+                <a:solidFill>
+                  <a:srgbClr val="444444"/>
+                </a:solidFill>
+              </a:defRPr>
+            </a:pPr>
+            <a:r>
+              <a:t>   Chi phí biên (MC) dịch lên trên</a:t>
+            </a:r>
+          </a:p>
+          <a:p>
+            <a:pPr>
+              <a:spcAft>
+                <a:spcPts val="500"/>
+              </a:spcAft>
+              <a:defRPr sz="1600">
+                <a:solidFill>
+                  <a:srgbClr val="444444"/>
                 </a:solidFill>
               </a:defRPr>
             </a:pPr>
@@ -3370,100 +3394,73 @@
           <a:p>
             <a:pPr>
               <a:spcAft>
-                <a:spcPts val="600"/>
-              </a:spcAft>
-              <a:defRPr sz="1700">
-                <a:solidFill>
-                  <a:srgbClr val="555555"/>
-                </a:solidFill>
-              </a:defRPr>
-            </a:pPr>
-          </a:p>
-          <a:p>
-            <a:pPr>
-              <a:spcAft>
-                <a:spcPts val="600"/>
-              </a:spcAft>
-              <a:defRPr sz="1700">
-                <a:solidFill>
-                  <a:srgbClr val="555555"/>
-                </a:solidFill>
-              </a:defRPr>
-            </a:pPr>
-            <a:r>
-              <a:t>Quyết định hợp lý:</a:t>
-            </a:r>
-          </a:p>
-          <a:p>
-            <a:pPr>
-              <a:spcAft>
-                <a:spcPts val="600"/>
-              </a:spcAft>
-              <a:defRPr sz="1700">
-                <a:solidFill>
-                  <a:srgbClr val="555555"/>
-                </a:solidFill>
-              </a:defRPr>
-            </a:pPr>
-            <a:r>
-              <a:t>   Giảm sản lượng (không sản xuất những xe lỗ)</a:t>
-            </a:r>
-          </a:p>
-          <a:p>
-            <a:pPr>
-              <a:spcAft>
-                <a:spcPts val="600"/>
-              </a:spcAft>
-              <a:defRPr sz="1700">
-                <a:solidFill>
-                  <a:srgbClr val="555555"/>
-                </a:solidFill>
-              </a:defRPr>
-            </a:pPr>
-            <a:r>
-              <a:t>   Tăng giá vừa phải (giữ thị phần)</a:t>
-            </a:r>
-          </a:p>
-          <a:p>
-            <a:pPr>
-              <a:spcAft>
-                <a:spcPts val="600"/>
-              </a:spcAft>
-              <a:defRPr sz="1700">
-                <a:solidFill>
-                  <a:srgbClr val="555555"/>
-                </a:solidFill>
-              </a:defRPr>
-            </a:pPr>
-          </a:p>
-          <a:p>
-            <a:pPr>
-              <a:spcAft>
-                <a:spcPts val="600"/>
-              </a:spcAft>
-              <a:defRPr sz="1700" b="1">
-                <a:solidFill>
-                  <a:srgbClr val="2D6A4F"/>
-                </a:solidFill>
-              </a:defRPr>
-            </a:pPr>
-            <a:r>
-              <a:t>→ Lợi thế quy mô giúp EcoDrive chịu đựng</a:t>
-            </a:r>
-          </a:p>
-          <a:p>
-            <a:pPr>
-              <a:spcAft>
-                <a:spcPts val="600"/>
-              </a:spcAft>
-              <a:defRPr sz="1700">
-                <a:solidFill>
-                  <a:srgbClr val="555555"/>
-                </a:solidFill>
-              </a:defRPr>
-            </a:pPr>
-            <a:r>
-              <a:t>   tốt hơn các đối thủ nhỏ</a:t>
+                <a:spcPts val="500"/>
+              </a:spcAft>
+              <a:defRPr sz="1600">
+                <a:solidFill>
+                  <a:srgbClr val="444444"/>
+                </a:solidFill>
+              </a:defRPr>
+            </a:pPr>
+          </a:p>
+          <a:p>
+            <a:pPr>
+              <a:spcAft>
+                <a:spcPts val="500"/>
+              </a:spcAft>
+              <a:defRPr sz="1600">
+                <a:solidFill>
+                  <a:srgbClr val="444444"/>
+                </a:solidFill>
+              </a:defRPr>
+            </a:pPr>
+            <a:r>
+              <a:t>Quyết định:</a:t>
+            </a:r>
+          </a:p>
+          <a:p>
+            <a:pPr>
+              <a:spcAft>
+                <a:spcPts val="500"/>
+              </a:spcAft>
+              <a:defRPr sz="1600">
+                <a:solidFill>
+                  <a:srgbClr val="444444"/>
+                </a:solidFill>
+              </a:defRPr>
+            </a:pPr>
+            <a:r>
+              <a:t>   • Giảm sản lượng xuống mức tối ưu mới</a:t>
+            </a:r>
+          </a:p>
+          <a:p>
+            <a:pPr>
+              <a:spcAft>
+                <a:spcPts val="500"/>
+              </a:spcAft>
+              <a:defRPr sz="1600">
+                <a:solidFill>
+                  <a:srgbClr val="444444"/>
+                </a:solidFill>
+              </a:defRPr>
+            </a:pPr>
+            <a:r>
+              <a:t>   • Tăng giá bán vừa phải (bù chi phí, giữ thị phần)</a:t>
+            </a:r>
+          </a:p>
+          <a:p>
+            <a:pPr>
+              <a:spcAft>
+                <a:spcPts val="500"/>
+              </a:spcAft>
+              <a:defRPr sz="1600">
+                <a:solidFill>
+                  <a:srgbClr val="444444"/>
+                </a:solidFill>
+              </a:defRPr>
+            </a:pPr>
+            <a:r>
+              <a:t>   • Lợi thế quy mô: chịu đựng tốt hơn đối thủ nhỏ</a:t>
             </a:r>
           </a:p>
         </p:txBody>
@@ -3494,8 +3491,8 @@
         </p:nvSpPr>
         <p:spPr>
           <a:xfrm>
-            <a:off x="540000" y="180000"/>
-            <a:ext cx="7920000" cy="648000"/>
+            <a:off x="540000" y="108000"/>
+            <a:ext cx="7920000" cy="720000"/>
           </a:xfrm>
           <a:prstGeom prst="rect">
             <a:avLst/>
@@ -3509,14 +3506,26 @@
           <a:lstStyle/>
           <a:p>
             <a:pPr>
-              <a:defRPr sz="2200" b="1">
+              <a:defRPr sz="2000" b="1">
                 <a:solidFill>
                   <a:srgbClr val="1B1B2F"/>
                 </a:solidFill>
               </a:defRPr>
             </a:pPr>
             <a:r>
-              <a:t>Nguyên tắc MR = MC: Sản xuất đến đâu thì dừng?</a:t>
+              <a:t>KếT LUẬN CÂU 3</a:t>
+            </a:r>
+          </a:p>
+          <a:p>
+            <a:pPr>
+              <a:defRPr sz="1200" i="1">
+                <a:solidFill>
+                  <a:srgbClr val="2D6A4F"/>
+                </a:solidFill>
+              </a:defRPr>
+            </a:pPr>
+            <a:r>
+              <a:t>Giảm sản lượng, tăng giá vừa phải. Lợi thế quy mô giúp chịu đựng tốt hơn đối thủ.</a:t>
             </a:r>
           </a:p>
         </p:txBody>
@@ -3537,8 +3546,8 @@
         </p:blipFill>
         <p:spPr>
           <a:xfrm>
-            <a:off x="432000" y="1007999"/>
-            <a:ext cx="8100000" cy="5338803"/>
+            <a:off x="360000" y="1007999"/>
+            <a:ext cx="8280000" cy="5449937"/>
           </a:xfrm>
           <a:prstGeom prst="rect">
             <a:avLst/>
@@ -3579,8 +3588,8 @@
         </p:nvSpPr>
         <p:spPr>
           <a:xfrm>
-            <a:off x="720000" y="2520000"/>
-            <a:ext cx="7560000" cy="1080000"/>
+            <a:off x="720000" y="2340000"/>
+            <a:ext cx="7560000" cy="1440000"/>
           </a:xfrm>
           <a:prstGeom prst="rect">
             <a:avLst/>
@@ -3594,14 +3603,26 @@
           <a:lstStyle/>
           <a:p>
             <a:pPr algn="ctr">
-              <a:defRPr sz="3200" b="1">
+              <a:defRPr sz="3000" b="1">
                 <a:solidFill>
                   <a:srgbClr val="FFFFFF"/>
                 </a:solidFill>
               </a:defRPr>
             </a:pPr>
             <a:r>
-              <a:t>LUẬT CHƠI MỚI CỦA THỊ TRƯỜNG</a:t>
+              <a:t>CẠNH TRANH PHI GIÁ</a:t>
+            </a:r>
+          </a:p>
+          <a:p>
+            <a:pPr algn="ctr">
+              <a:defRPr sz="1400">
+                <a:solidFill>
+                  <a:srgbClr val="CCCCCC"/>
+                </a:solidFill>
+              </a:defRPr>
+            </a:pPr>
+            <a:r>
+              <a:t>Trả lời câu hỏi 4</a:t>
             </a:r>
           </a:p>
         </p:txBody>
@@ -3632,8 +3653,8 @@
         </p:nvSpPr>
         <p:spPr>
           <a:xfrm>
-            <a:off x="540000" y="180000"/>
-            <a:ext cx="7920000" cy="648000"/>
+            <a:off x="540000" y="108000"/>
+            <a:ext cx="7920000" cy="720000"/>
           </a:xfrm>
           <a:prstGeom prst="rect">
             <a:avLst/>
@@ -3647,14 +3668,26 @@
           <a:lstStyle/>
           <a:p>
             <a:pPr>
-              <a:defRPr sz="2200" b="1">
+              <a:defRPr sz="2000" b="1">
                 <a:solidFill>
                   <a:srgbClr val="1B1B2F"/>
                 </a:solidFill>
               </a:defRPr>
             </a:pPr>
             <a:r>
-              <a:t>Cấu trúc thị trường đã thay đổi hoàn toàn</a:t>
+              <a:t>CẤU TRÚC THỊ TRƯỜNG ĐÃ THAY ĐỔI</a:t>
+            </a:r>
+          </a:p>
+          <a:p>
+            <a:pPr>
+              <a:defRPr sz="1200" i="1">
+                <a:solidFill>
+                  <a:srgbClr val="2D6A4F"/>
+                </a:solidFill>
+              </a:defRPr>
+            </a:pPr>
+            <a:r>
+              <a:t>Từ độc quyền → Độc quyền nhóm / Cạnh tranh độc quyền</a:t>
             </a:r>
           </a:p>
         </p:txBody>
@@ -3675,8 +3708,8 @@
         </p:blipFill>
         <p:spPr>
           <a:xfrm>
-            <a:off x="432000" y="1007999"/>
-            <a:ext cx="8100000" cy="2763851"/>
+            <a:off x="360000" y="1007999"/>
+            <a:ext cx="8280000" cy="2808486"/>
           </a:xfrm>
           <a:prstGeom prst="rect">
             <a:avLst/>
@@ -3709,8 +3742,8 @@
         </p:nvSpPr>
         <p:spPr>
           <a:xfrm>
-            <a:off x="540000" y="288000"/>
-            <a:ext cx="7920000" cy="792000"/>
+            <a:off x="540000" y="216000"/>
+            <a:ext cx="7920000" cy="720000"/>
           </a:xfrm>
           <a:prstGeom prst="rect">
             <a:avLst/>
@@ -3724,14 +3757,26 @@
           <a:lstStyle/>
           <a:p>
             <a:pPr>
-              <a:defRPr sz="2600" b="1">
+              <a:defRPr sz="2400" b="1">
                 <a:solidFill>
                   <a:srgbClr val="1B1B2F"/>
                 </a:solidFill>
               </a:defRPr>
             </a:pPr>
             <a:r>
-              <a:t>TẠI SAO KHÔNG AI ĐUA GIÁ?</a:t>
+              <a:t>TẠI SAO ĐUA R&amp;D THAY VÌ ĐUA GIÁ?</a:t>
+            </a:r>
+          </a:p>
+          <a:p>
+            <a:pPr>
+              <a:defRPr sz="1200" i="1">
+                <a:solidFill>
+                  <a:srgbClr val="2D6A4F"/>
+                </a:solidFill>
+              </a:defRPr>
+            </a:pPr>
+            <a:r>
+              <a:t>Câu 4: Tại sao không đua giá? Vai trò khác biệt hóa?</a:t>
             </a:r>
           </a:p>
         </p:txBody>
@@ -3744,8 +3789,8 @@
         </p:nvSpPr>
         <p:spPr>
           <a:xfrm>
-            <a:off x="648000" y="1152000"/>
-            <a:ext cx="7560000" cy="5040000"/>
+            <a:off x="648000" y="1080000"/>
+            <a:ext cx="7560000" cy="5220000"/>
           </a:xfrm>
           <a:prstGeom prst="rect">
             <a:avLst/>
@@ -3760,125 +3805,98 @@
           <a:p>
             <a:pPr>
               <a:spcAft>
-                <a:spcPts val="600"/>
-              </a:spcAft>
-              <a:defRPr sz="1700">
-                <a:solidFill>
-                  <a:srgbClr val="555555"/>
-                </a:solidFill>
-              </a:defRPr>
-            </a:pPr>
-            <a:r>
-              <a:t>Chiến tranh giá = tất cả cùng thua</a:t>
-            </a:r>
-          </a:p>
-          <a:p>
-            <a:pPr>
-              <a:spcAft>
-                <a:spcPts val="600"/>
-              </a:spcAft>
-              <a:defRPr sz="1700">
-                <a:solidFill>
-                  <a:srgbClr val="555555"/>
-                </a:solidFill>
-              </a:defRPr>
-            </a:pPr>
-            <a:r>
-              <a:t>   Hãng A giảm → Hãng B giảm → C giảm → không ai lãi</a:t>
-            </a:r>
-          </a:p>
-          <a:p>
-            <a:pPr>
-              <a:spcAft>
-                <a:spcPts val="600"/>
-              </a:spcAft>
-              <a:defRPr sz="1700">
-                <a:solidFill>
-                  <a:srgbClr val="555555"/>
-                </a:solidFill>
-              </a:defRPr>
-            </a:pPr>
-          </a:p>
-          <a:p>
-            <a:pPr>
-              <a:spcAft>
-                <a:spcPts val="600"/>
-              </a:spcAft>
-              <a:defRPr sz="1700">
-                <a:solidFill>
-                  <a:srgbClr val="555555"/>
-                </a:solidFill>
-              </a:defRPr>
-            </a:pPr>
-            <a:r>
-              <a:t>Thay vào đó: đầu tư R&amp;D và quảng cáo</a:t>
-            </a:r>
-          </a:p>
-          <a:p>
-            <a:pPr>
-              <a:spcAft>
-                <a:spcPts val="600"/>
-              </a:spcAft>
-              <a:defRPr sz="1700">
-                <a:solidFill>
-                  <a:srgbClr val="555555"/>
-                </a:solidFill>
-              </a:defRPr>
-            </a:pPr>
-            <a:r>
-              <a:t>   Tự lái, nội thất thông minh, hệ sinh thái riêng</a:t>
-            </a:r>
-          </a:p>
-          <a:p>
-            <a:pPr>
-              <a:spcAft>
-                <a:spcPts val="600"/>
-              </a:spcAft>
-              <a:defRPr sz="1700">
-                <a:solidFill>
-                  <a:srgbClr val="555555"/>
-                </a:solidFill>
-              </a:defRPr>
-            </a:pPr>
-            <a:r>
-              <a:t>   Tạo sản phẩm “không giống ai”</a:t>
-            </a:r>
-          </a:p>
-          <a:p>
-            <a:pPr>
-              <a:spcAft>
-                <a:spcPts val="600"/>
-              </a:spcAft>
-              <a:defRPr sz="1700">
-                <a:solidFill>
-                  <a:srgbClr val="555555"/>
-                </a:solidFill>
-              </a:defRPr>
-            </a:pPr>
-          </a:p>
-          <a:p>
-            <a:pPr>
-              <a:spcAft>
-                <a:spcPts val="600"/>
-              </a:spcAft>
-              <a:defRPr sz="1700">
-                <a:solidFill>
-                  <a:srgbClr val="555555"/>
-                </a:solidFill>
-              </a:defRPr>
-            </a:pPr>
-            <a:r>
-              <a:t>Kết quả:</a:t>
-            </a:r>
-          </a:p>
-          <a:p>
-            <a:pPr>
-              <a:spcAft>
-                <a:spcPts val="600"/>
-              </a:spcAft>
-              <a:defRPr sz="1700">
-                <a:solidFill>
-                  <a:srgbClr val="555555"/>
+                <a:spcPts val="500"/>
+              </a:spcAft>
+              <a:defRPr sz="1600">
+                <a:solidFill>
+                  <a:srgbClr val="444444"/>
+                </a:solidFill>
+              </a:defRPr>
+            </a:pPr>
+            <a:r>
+              <a:t>Đua giá = đường cùng:</a:t>
+            </a:r>
+          </a:p>
+          <a:p>
+            <a:pPr>
+              <a:spcAft>
+                <a:spcPts val="500"/>
+              </a:spcAft>
+              <a:defRPr sz="1600">
+                <a:solidFill>
+                  <a:srgbClr val="444444"/>
+                </a:solidFill>
+              </a:defRPr>
+            </a:pPr>
+            <a:r>
+              <a:t>   Hãng A giảm → B giảm → tất cả lỗ</a:t>
+            </a:r>
+          </a:p>
+          <a:p>
+            <a:pPr>
+              <a:spcAft>
+                <a:spcPts val="500"/>
+              </a:spcAft>
+              <a:defRPr sz="1600">
+                <a:solidFill>
+                  <a:srgbClr val="444444"/>
+                </a:solidFill>
+              </a:defRPr>
+            </a:pPr>
+            <a:r>
+              <a:t>   Lithium đắt → không còn dư địa giảm</a:t>
+            </a:r>
+          </a:p>
+          <a:p>
+            <a:pPr>
+              <a:spcAft>
+                <a:spcPts val="500"/>
+              </a:spcAft>
+              <a:defRPr sz="1600">
+                <a:solidFill>
+                  <a:srgbClr val="444444"/>
+                </a:solidFill>
+              </a:defRPr>
+            </a:pPr>
+          </a:p>
+          <a:p>
+            <a:pPr>
+              <a:spcAft>
+                <a:spcPts val="500"/>
+              </a:spcAft>
+              <a:defRPr sz="1600">
+                <a:solidFill>
+                  <a:srgbClr val="444444"/>
+                </a:solidFill>
+              </a:defRPr>
+            </a:pPr>
+            <a:r>
+              <a:t>Đua R&amp;D + Quảng cáo = tạo quyền lực:</a:t>
+            </a:r>
+          </a:p>
+          <a:p>
+            <a:pPr>
+              <a:spcAft>
+                <a:spcPts val="500"/>
+              </a:spcAft>
+              <a:defRPr sz="1600">
+                <a:solidFill>
+                  <a:srgbClr val="444444"/>
+                </a:solidFill>
+              </a:defRPr>
+            </a:pPr>
+            <a:r>
+              <a:t>   Sản phẩm "không giống ai" (tự lái, nội thất thông minh)</a:t>
+            </a:r>
+          </a:p>
+          <a:p>
+            <a:pPr>
+              <a:spcAft>
+                <a:spcPts val="500"/>
+              </a:spcAft>
+              <a:defRPr sz="1600">
+                <a:solidFill>
+                  <a:srgbClr val="444444"/>
                 </a:solidFill>
               </a:defRPr>
             </a:pPr>
@@ -3889,11 +3907,11 @@
           <a:p>
             <a:pPr>
               <a:spcAft>
-                <a:spcPts val="600"/>
-              </a:spcAft>
-              <a:defRPr sz="1700">
-                <a:solidFill>
-                  <a:srgbClr val="555555"/>
+                <a:spcPts val="500"/>
+              </a:spcAft>
+              <a:defRPr sz="1600">
+                <a:solidFill>
+                  <a:srgbClr val="444444"/>
                 </a:solidFill>
               </a:defRPr>
             </a:pPr>
@@ -3904,28 +3922,28 @@
           <a:p>
             <a:pPr>
               <a:spcAft>
-                <a:spcPts val="600"/>
-              </a:spcAft>
-              <a:defRPr sz="1700">
-                <a:solidFill>
-                  <a:srgbClr val="555555"/>
-                </a:solidFill>
-              </a:defRPr>
-            </a:pPr>
-          </a:p>
-          <a:p>
-            <a:pPr>
-              <a:spcAft>
-                <a:spcPts val="600"/>
-              </a:spcAft>
-              <a:defRPr sz="1700" b="1">
+                <a:spcPts val="500"/>
+              </a:spcAft>
+              <a:defRPr sz="1600">
+                <a:solidFill>
+                  <a:srgbClr val="444444"/>
+                </a:solidFill>
+              </a:defRPr>
+            </a:pPr>
+          </a:p>
+          <a:p>
+            <a:pPr>
+              <a:spcAft>
+                <a:spcPts val="500"/>
+              </a:spcAft>
+              <a:defRPr sz="1600" b="1">
                 <a:solidFill>
                   <a:srgbClr val="2D6A4F"/>
                 </a:solidFill>
               </a:defRPr>
             </a:pPr>
             <a:r>
-              <a:t>→ Cạnh tranh bằng GIÁ TRỊ, không bằng giá bán</a:t>
+              <a:t>→ Khác biệt hóa giảm độ co giãn của cầu theo giá</a:t>
             </a:r>
           </a:p>
         </p:txBody>
@@ -3956,8 +3974,8 @@
         </p:nvSpPr>
         <p:spPr>
           <a:xfrm>
-            <a:off x="540000" y="180000"/>
-            <a:ext cx="7920000" cy="648000"/>
+            <a:off x="540000" y="108000"/>
+            <a:ext cx="7920000" cy="720000"/>
           </a:xfrm>
           <a:prstGeom prst="rect">
             <a:avLst/>
@@ -3971,14 +3989,26 @@
           <a:lstStyle/>
           <a:p>
             <a:pPr>
-              <a:defRPr sz="2200" b="1">
+              <a:defRPr sz="2000" b="1">
                 <a:solidFill>
                   <a:srgbClr val="1B1B2F"/>
                 </a:solidFill>
               </a:defRPr>
             </a:pPr>
             <a:r>
-              <a:t>Khác biệt hóa → Cầu ít co giãn → Quyền lực cao</a:t>
+              <a:t>KếT LUẬN CÂU 4</a:t>
+            </a:r>
+          </a:p>
+          <a:p>
+            <a:pPr>
+              <a:defRPr sz="1200" i="1">
+                <a:solidFill>
+                  <a:srgbClr val="2D6A4F"/>
+                </a:solidFill>
+              </a:defRPr>
+            </a:pPr>
+            <a:r>
+              <a:t>Khác biệt hóa → Khách trung thành → Cầu ít co giãn → Giữ giá cao được</a:t>
             </a:r>
           </a:p>
         </p:txBody>
@@ -3999,8 +4029,8 @@
         </p:blipFill>
         <p:spPr>
           <a:xfrm>
-            <a:off x="432000" y="1007999"/>
-            <a:ext cx="8100000" cy="3247946"/>
+            <a:off x="360000" y="1007999"/>
+            <a:ext cx="8280000" cy="3233820"/>
           </a:xfrm>
           <a:prstGeom prst="rect">
             <a:avLst/>
@@ -4033,8 +4063,8 @@
         </p:nvSpPr>
         <p:spPr>
           <a:xfrm>
-            <a:off x="540000" y="288000"/>
-            <a:ext cx="7920000" cy="792000"/>
+            <a:off x="540000" y="216000"/>
+            <a:ext cx="7920000" cy="720000"/>
           </a:xfrm>
           <a:prstGeom prst="rect">
             <a:avLst/>
@@ -4048,14 +4078,14 @@
           <a:lstStyle/>
           <a:p>
             <a:pPr>
-              <a:defRPr sz="2600" b="1">
+              <a:defRPr sz="2400" b="1">
                 <a:solidFill>
                   <a:srgbClr val="1B1B2F"/>
                 </a:solidFill>
               </a:defRPr>
             </a:pPr>
             <a:r>
-              <a:t>ĐÁNH GIÁ TỔNG KẾT</a:t>
+              <a:t>ĐÁNH GIÁ TỔNG KếT</a:t>
             </a:r>
           </a:p>
         </p:txBody>
@@ -4068,8 +4098,8 @@
         </p:nvSpPr>
         <p:spPr>
           <a:xfrm>
-            <a:off x="648000" y="1152000"/>
-            <a:ext cx="7560000" cy="5040000"/>
+            <a:off x="648000" y="1080000"/>
+            <a:ext cx="7560000" cy="5220000"/>
           </a:xfrm>
           <a:prstGeom prst="rect">
             <a:avLst/>
@@ -4084,157 +4114,157 @@
           <a:p>
             <a:pPr>
               <a:spcAft>
-                <a:spcPts val="600"/>
-              </a:spcAft>
-              <a:defRPr sz="1700" b="1">
+                <a:spcPts val="500"/>
+              </a:spcAft>
+              <a:defRPr sz="1600" b="1">
                 <a:solidFill>
                   <a:srgbClr val="2D6A4F"/>
                 </a:solidFill>
               </a:defRPr>
             </a:pPr>
             <a:r>
-              <a:t>✓ Thị trường xe điện Alpha chịu áp lực giá tăng</a:t>
-            </a:r>
-          </a:p>
-          <a:p>
-            <a:pPr>
-              <a:spcAft>
-                <a:spcPts val="600"/>
-              </a:spcAft>
-              <a:defRPr sz="1700">
-                <a:solidFill>
-                  <a:srgbClr val="555555"/>
-                </a:solidFill>
-              </a:defRPr>
-            </a:pPr>
-            <a:r>
-              <a:t>   vì cầu bùng nổ trong khi cung bị kìm hãm</a:t>
-            </a:r>
-          </a:p>
-          <a:p>
-            <a:pPr>
-              <a:spcAft>
-                <a:spcPts val="600"/>
-              </a:spcAft>
-              <a:defRPr sz="1700">
-                <a:solidFill>
-                  <a:srgbClr val="555555"/>
-                </a:solidFill>
-              </a:defRPr>
-            </a:pPr>
-          </a:p>
-          <a:p>
-            <a:pPr>
-              <a:spcAft>
-                <a:spcPts val="600"/>
-              </a:spcAft>
-              <a:defRPr sz="1700" b="1">
+              <a:t>✓ Câu 1: Thị trường chịu áp lực giá TĂNG</a:t>
+            </a:r>
+          </a:p>
+          <a:p>
+            <a:pPr>
+              <a:spcAft>
+                <a:spcPts val="500"/>
+              </a:spcAft>
+              <a:defRPr sz="1600">
+                <a:solidFill>
+                  <a:srgbClr val="444444"/>
+                </a:solidFill>
+              </a:defRPr>
+            </a:pPr>
+            <a:r>
+              <a:t>   Cầu bùng nổ, Cung bị kìm bởi nguyên liệu</a:t>
+            </a:r>
+          </a:p>
+          <a:p>
+            <a:pPr>
+              <a:spcAft>
+                <a:spcPts val="500"/>
+              </a:spcAft>
+              <a:defRPr sz="1600">
+                <a:solidFill>
+                  <a:srgbClr val="444444"/>
+                </a:solidFill>
+              </a:defRPr>
+            </a:pPr>
+          </a:p>
+          <a:p>
+            <a:pPr>
+              <a:spcAft>
+                <a:spcPts val="500"/>
+              </a:spcAft>
+              <a:defRPr sz="1600" b="1">
                 <a:solidFill>
                   <a:srgbClr val="2D6A4F"/>
                 </a:solidFill>
               </a:defRPr>
             </a:pPr>
             <a:r>
-              <a:t>✓ Chính sách chỉ hiệu quả nếu kiểm soát được</a:t>
-            </a:r>
-          </a:p>
-          <a:p>
-            <a:pPr>
-              <a:spcAft>
-                <a:spcPts val="600"/>
-              </a:spcAft>
-              <a:defRPr sz="1700">
-                <a:solidFill>
-                  <a:srgbClr val="555555"/>
-                </a:solidFill>
-              </a:defRPr>
-            </a:pPr>
-            <a:r>
-              <a:t>   toàn bộ hệ thống hàng hóa liên quan</a:t>
-            </a:r>
-          </a:p>
-          <a:p>
-            <a:pPr>
-              <a:spcAft>
-                <a:spcPts val="600"/>
-              </a:spcAft>
-              <a:defRPr sz="1700">
-                <a:solidFill>
-                  <a:srgbClr val="555555"/>
-                </a:solidFill>
-              </a:defRPr>
-            </a:pPr>
-          </a:p>
-          <a:p>
-            <a:pPr>
-              <a:spcAft>
-                <a:spcPts val="600"/>
-              </a:spcAft>
-              <a:defRPr sz="1700" b="1">
+              <a:t>✓ Câu 2: Hàng bổ sung đắt → Xoi mòn lợi ích cận biên</a:t>
+            </a:r>
+          </a:p>
+          <a:p>
+            <a:pPr>
+              <a:spcAft>
+                <a:spcPts val="500"/>
+              </a:spcAft>
+              <a:defRPr sz="1600">
+                <a:solidFill>
+                  <a:srgbClr val="444444"/>
+                </a:solidFill>
+              </a:defRPr>
+            </a:pPr>
+            <a:r>
+              <a:t>   Chính sách chỉ hiệu quả khi kiểm soát cả hệ thống</a:t>
+            </a:r>
+          </a:p>
+          <a:p>
+            <a:pPr>
+              <a:spcAft>
+                <a:spcPts val="500"/>
+              </a:spcAft>
+              <a:defRPr sz="1600">
+                <a:solidFill>
+                  <a:srgbClr val="444444"/>
+                </a:solidFill>
+              </a:defRPr>
+            </a:pPr>
+          </a:p>
+          <a:p>
+            <a:pPr>
+              <a:spcAft>
+                <a:spcPts val="500"/>
+              </a:spcAft>
+              <a:defRPr sz="1600" b="1">
                 <a:solidFill>
                   <a:srgbClr val="2D6A4F"/>
                 </a:solidFill>
               </a:defRPr>
             </a:pPr>
             <a:r>
-              <a:t>✓ Doanh nghiệp thống trị không tối đa sản lượng</a:t>
-            </a:r>
-          </a:p>
-          <a:p>
-            <a:pPr>
-              <a:spcAft>
-                <a:spcPts val="600"/>
-              </a:spcAft>
-              <a:defRPr sz="1700">
-                <a:solidFill>
-                  <a:srgbClr val="555555"/>
-                </a:solidFill>
-              </a:defRPr>
-            </a:pPr>
-            <a:r>
-              <a:t>   mà tối đa lợi nhuận qua nguyên tắc MR=MC</a:t>
-            </a:r>
-          </a:p>
-          <a:p>
-            <a:pPr>
-              <a:spcAft>
-                <a:spcPts val="600"/>
-              </a:spcAft>
-              <a:defRPr sz="1700">
-                <a:solidFill>
-                  <a:srgbClr val="555555"/>
-                </a:solidFill>
-              </a:defRPr>
-            </a:pPr>
-          </a:p>
-          <a:p>
-            <a:pPr>
-              <a:spcAft>
-                <a:spcPts val="600"/>
-              </a:spcAft>
-              <a:defRPr sz="1700" b="1">
+              <a:t>✓ Câu 3: MR=MC → Giảm Q, tăng P vừa phải</a:t>
+            </a:r>
+          </a:p>
+          <a:p>
+            <a:pPr>
+              <a:spcAft>
+                <a:spcPts val="500"/>
+              </a:spcAft>
+              <a:defRPr sz="1600">
+                <a:solidFill>
+                  <a:srgbClr val="444444"/>
+                </a:solidFill>
+              </a:defRPr>
+            </a:pPr>
+            <a:r>
+              <a:t>   Lợi thế quy mô giúp EcoDrive chịu đựng tốt hơn</a:t>
+            </a:r>
+          </a:p>
+          <a:p>
+            <a:pPr>
+              <a:spcAft>
+                <a:spcPts val="500"/>
+              </a:spcAft>
+              <a:defRPr sz="1600">
+                <a:solidFill>
+                  <a:srgbClr val="444444"/>
+                </a:solidFill>
+              </a:defRPr>
+            </a:pPr>
+          </a:p>
+          <a:p>
+            <a:pPr>
+              <a:spcAft>
+                <a:spcPts val="500"/>
+              </a:spcAft>
+              <a:defRPr sz="1600" b="1">
                 <a:solidFill>
                   <a:srgbClr val="2D6A4F"/>
                 </a:solidFill>
               </a:defRPr>
             </a:pPr>
             <a:r>
-              <a:t>✓ Trong môi trường cạnh tranh mới,</a:t>
-            </a:r>
-          </a:p>
-          <a:p>
-            <a:pPr>
-              <a:spcAft>
-                <a:spcPts val="600"/>
-              </a:spcAft>
-              <a:defRPr sz="1700">
-                <a:solidFill>
-                  <a:srgbClr val="555555"/>
-                </a:solidFill>
-              </a:defRPr>
-            </a:pPr>
-            <a:r>
-              <a:t>   đua giá trị thắng đua giá bán</a:t>
+              <a:t>✓ Câu 4: Đua giá trị thắng đua giá bán</a:t>
+            </a:r>
+          </a:p>
+          <a:p>
+            <a:pPr>
+              <a:spcAft>
+                <a:spcPts val="500"/>
+              </a:spcAft>
+              <a:defRPr sz="1600">
+                <a:solidFill>
+                  <a:srgbClr val="444444"/>
+                </a:solidFill>
+              </a:defRPr>
+            </a:pPr>
+            <a:r>
+              <a:t>   Khác biệt hóa = vũ khí giữ quyền lực thị trường</a:t>
             </a:r>
           </a:p>
         </p:txBody>
@@ -4273,8 +4303,8 @@
         </p:nvSpPr>
         <p:spPr>
           <a:xfrm>
-            <a:off x="720000" y="2160000"/>
-            <a:ext cx="7560000" cy="1440000"/>
+            <a:off x="720000" y="1980000"/>
+            <a:ext cx="7560000" cy="1800000"/>
           </a:xfrm>
           <a:prstGeom prst="rect">
             <a:avLst/>
@@ -4288,7 +4318,7 @@
           <a:lstStyle/>
           <a:p>
             <a:pPr algn="ctr">
-              <a:defRPr sz="3600" b="1">
+              <a:defRPr sz="3400" b="1">
                 <a:solidFill>
                   <a:srgbClr val="FFFFFF"/>
                 </a:solidFill>
@@ -4300,9 +4330,9 @@
           </a:p>
           <a:p>
             <a:pPr algn="ctr">
-              <a:defRPr sz="1800">
-                <a:solidFill>
-                  <a:srgbClr val="CCCCCC"/>
+              <a:defRPr sz="1600">
+                <a:solidFill>
+                  <a:srgbClr val="BBBBBB"/>
                 </a:solidFill>
               </a:defRPr>
             </a:pPr>
@@ -4338,8 +4368,8 @@
         </p:nvSpPr>
         <p:spPr>
           <a:xfrm>
-            <a:off x="540000" y="288000"/>
-            <a:ext cx="7920000" cy="792000"/>
+            <a:off x="540000" y="216000"/>
+            <a:ext cx="7920000" cy="720000"/>
           </a:xfrm>
           <a:prstGeom prst="rect">
             <a:avLst/>
@@ -4353,14 +4383,14 @@
           <a:lstStyle/>
           <a:p>
             <a:pPr>
-              <a:defRPr sz="2600" b="1">
+              <a:defRPr sz="2400" b="1">
                 <a:solidFill>
                   <a:srgbClr val="1B1B2F"/>
                 </a:solidFill>
               </a:defRPr>
             </a:pPr>
             <a:r>
-              <a:t>BỐI CẢNH</a:t>
+              <a:t>BỐI CẢNH TÌNH HUỐNG</a:t>
             </a:r>
           </a:p>
         </p:txBody>
@@ -4373,8 +4403,8 @@
         </p:nvSpPr>
         <p:spPr>
           <a:xfrm>
-            <a:off x="648000" y="1152000"/>
-            <a:ext cx="7560000" cy="5040000"/>
+            <a:off x="648000" y="1080000"/>
+            <a:ext cx="7560000" cy="5220000"/>
           </a:xfrm>
           <a:prstGeom prst="rect">
             <a:avLst/>
@@ -4389,122 +4419,56 @@
           <a:p>
             <a:pPr>
               <a:spcAft>
-                <a:spcPts val="600"/>
-              </a:spcAft>
-              <a:defRPr sz="1700">
-                <a:solidFill>
-                  <a:srgbClr val="555555"/>
-                </a:solidFill>
-              </a:defRPr>
-            </a:pPr>
-            <a:r>
-              <a:t>Quốc gia Alpha: lộ trình khai tử xe xăng năm 2035</a:t>
-            </a:r>
-          </a:p>
-          <a:p>
-            <a:pPr>
-              <a:spcAft>
-                <a:spcPts val="600"/>
-              </a:spcAft>
-              <a:defRPr sz="1700">
-                <a:solidFill>
-                  <a:srgbClr val="555555"/>
-                </a:solidFill>
-              </a:defRPr>
-            </a:pPr>
-          </a:p>
-          <a:p>
-            <a:pPr>
-              <a:spcAft>
-                <a:spcPts val="600"/>
-              </a:spcAft>
-              <a:defRPr sz="1700">
-                <a:solidFill>
-                  <a:srgbClr val="555555"/>
-                </a:solidFill>
-              </a:defRPr>
-            </a:pPr>
-            <a:r>
-              <a:t>Chính sách kép:</a:t>
-            </a:r>
-          </a:p>
-          <a:p>
-            <a:pPr>
-              <a:spcAft>
-                <a:spcPts val="600"/>
-              </a:spcAft>
-              <a:defRPr sz="1700">
-                <a:solidFill>
-                  <a:srgbClr val="555555"/>
-                </a:solidFill>
-              </a:defRPr>
-            </a:pPr>
-            <a:r>
-              <a:t>   • Thuế tiêu thụ đặc biệt vào xe xăng tăng vọt</a:t>
-            </a:r>
-          </a:p>
-          <a:p>
-            <a:pPr>
-              <a:spcAft>
-                <a:spcPts val="600"/>
-              </a:spcAft>
-              <a:defRPr sz="1700">
-                <a:solidFill>
-                  <a:srgbClr val="555555"/>
-                </a:solidFill>
-              </a:defRPr>
-            </a:pPr>
-            <a:r>
-              <a:t>   • Trợ cấp trực tiếp cho người mua xe điện</a:t>
-            </a:r>
-          </a:p>
-          <a:p>
-            <a:pPr>
-              <a:spcAft>
-                <a:spcPts val="600"/>
-              </a:spcAft>
-              <a:defRPr sz="1700">
-                <a:solidFill>
-                  <a:srgbClr val="555555"/>
-                </a:solidFill>
-              </a:defRPr>
-            </a:pPr>
-          </a:p>
-          <a:p>
-            <a:pPr>
-              <a:spcAft>
-                <a:spcPts val="600"/>
-              </a:spcAft>
-              <a:defRPr sz="1700">
-                <a:solidFill>
-                  <a:srgbClr val="555555"/>
-                </a:solidFill>
-              </a:defRPr>
-            </a:pPr>
-            <a:r>
-              <a:t>Thu nhập bình quân đầu người: +10%/năm</a:t>
-            </a:r>
-          </a:p>
-          <a:p>
-            <a:pPr>
-              <a:spcAft>
-                <a:spcPts val="600"/>
-              </a:spcAft>
-              <a:defRPr sz="1700">
-                <a:solidFill>
-                  <a:srgbClr val="555555"/>
-                </a:solidFill>
-              </a:defRPr>
-            </a:pPr>
-          </a:p>
-          <a:p>
-            <a:pPr>
-              <a:spcAft>
-                <a:spcPts val="600"/>
-              </a:spcAft>
-              <a:defRPr sz="1700">
-                <a:solidFill>
-                  <a:srgbClr val="555555"/>
+                <a:spcPts val="500"/>
+              </a:spcAft>
+              <a:defRPr sz="1600">
+                <a:solidFill>
+                  <a:srgbClr val="444444"/>
+                </a:solidFill>
+              </a:defRPr>
+            </a:pPr>
+            <a:r>
+              <a:t>Quốc gia Alpha: khai tử xe xăng năm 2035</a:t>
+            </a:r>
+          </a:p>
+          <a:p>
+            <a:pPr>
+              <a:spcAft>
+                <a:spcPts val="500"/>
+              </a:spcAft>
+              <a:defRPr sz="1600">
+                <a:solidFill>
+                  <a:srgbClr val="444444"/>
+                </a:solidFill>
+              </a:defRPr>
+            </a:pPr>
+            <a:r>
+              <a:t>Chính sách kép: Thuế xe xăng ↑ + Trợ cấp xe điện</a:t>
+            </a:r>
+          </a:p>
+          <a:p>
+            <a:pPr>
+              <a:spcAft>
+                <a:spcPts val="500"/>
+              </a:spcAft>
+              <a:defRPr sz="1600">
+                <a:solidFill>
+                  <a:srgbClr val="444444"/>
+                </a:solidFill>
+              </a:defRPr>
+            </a:pPr>
+            <a:r>
+              <a:t>Thu nhập bình quân: tăng ổn định 10%/năm</a:t>
+            </a:r>
+          </a:p>
+          <a:p>
+            <a:pPr>
+              <a:spcAft>
+                <a:spcPts val="500"/>
+              </a:spcAft>
+              <a:defRPr sz="1600">
+                <a:solidFill>
+                  <a:srgbClr val="444444"/>
                 </a:solidFill>
               </a:defRPr>
             </a:pPr>
@@ -4515,28 +4479,46 @@
           <a:p>
             <a:pPr>
               <a:spcAft>
-                <a:spcPts val="600"/>
-              </a:spcAft>
-              <a:defRPr sz="1700">
-                <a:solidFill>
-                  <a:srgbClr val="555555"/>
-                </a:solidFill>
-              </a:defRPr>
-            </a:pPr>
-          </a:p>
-          <a:p>
-            <a:pPr>
-              <a:spcAft>
-                <a:spcPts val="600"/>
-              </a:spcAft>
-              <a:defRPr sz="1700">
-                <a:solidFill>
-                  <a:srgbClr val="555555"/>
-                </a:solidFill>
-              </a:defRPr>
-            </a:pPr>
-            <a:r>
-              <a:t>Thách thức: Lithium tăng giá, 10+ đối thủ ngoại quốc, giá điện sạc tăng</a:t>
+                <a:spcPts val="500"/>
+              </a:spcAft>
+              <a:defRPr sz="1600">
+                <a:solidFill>
+                  <a:srgbClr val="444444"/>
+                </a:solidFill>
+              </a:defRPr>
+            </a:pPr>
+            <a:r>
+              <a:t>10+ đối thủ ngoại quốc xâm nhập</a:t>
+            </a:r>
+          </a:p>
+          <a:p>
+            <a:pPr>
+              <a:spcAft>
+                <a:spcPts val="500"/>
+              </a:spcAft>
+              <a:defRPr sz="1600">
+                <a:solidFill>
+                  <a:srgbClr val="444444"/>
+                </a:solidFill>
+              </a:defRPr>
+            </a:pPr>
+            <a:r>
+              <a:t>Lithium tăng giá (chuỗi cung ứng đứt gãy)</a:t>
+            </a:r>
+          </a:p>
+          <a:p>
+            <a:pPr>
+              <a:spcAft>
+                <a:spcPts val="500"/>
+              </a:spcAft>
+              <a:defRPr sz="1600">
+                <a:solidFill>
+                  <a:srgbClr val="444444"/>
+                </a:solidFill>
+              </a:defRPr>
+            </a:pPr>
+            <a:r>
+              <a:t>Giá điện sạc có xu hướng tăng</a:t>
             </a:r>
           </a:p>
         </p:txBody>
@@ -4550,6 +4532,247 @@
 </file>
 
 <file path=ppt/slides/slide3.xml><?xml version="1.0" encoding="utf-8"?>
+<p:sld xmlns:a="http://schemas.openxmlformats.org/drawingml/2006/main" xmlns:p="http://schemas.openxmlformats.org/presentationml/2006/main" xmlns:r="http://schemas.openxmlformats.org/officeDocument/2006/relationships">
+  <p:cSld>
+    <p:spTree>
+      <p:nvGrpSpPr>
+        <p:cNvPr id="1" name=""/>
+        <p:cNvGrpSpPr/>
+        <p:nvPr/>
+      </p:nvGrpSpPr>
+      <p:grpSpPr/>
+      <p:sp>
+        <p:nvSpPr>
+          <p:cNvPr id="2" name="TextBox 1"/>
+          <p:cNvSpPr txBox="1"/>
+          <p:nvPr/>
+        </p:nvSpPr>
+        <p:spPr>
+          <a:xfrm>
+            <a:off x="540000" y="216000"/>
+            <a:ext cx="7920000" cy="720000"/>
+          </a:xfrm>
+          <a:prstGeom prst="rect">
+            <a:avLst/>
+          </a:prstGeom>
+          <a:noFill/>
+        </p:spPr>
+        <p:txBody>
+          <a:bodyPr wrap="square">
+            <a:spAutoFit/>
+          </a:bodyPr>
+          <a:lstStyle/>
+          <a:p>
+            <a:pPr>
+              <a:defRPr sz="2400" b="1">
+                <a:solidFill>
+                  <a:srgbClr val="1B1B2F"/>
+                </a:solidFill>
+              </a:defRPr>
+            </a:pPr>
+            <a:r>
+              <a:t>BÓC TÁCH DỮ LIỆU</a:t>
+            </a:r>
+          </a:p>
+        </p:txBody>
+      </p:sp>
+      <p:sp>
+        <p:nvSpPr>
+          <p:cNvPr id="3" name="TextBox 2"/>
+          <p:cNvSpPr txBox="1"/>
+          <p:nvPr/>
+        </p:nvSpPr>
+        <p:spPr>
+          <a:xfrm>
+            <a:off x="648000" y="1080000"/>
+            <a:ext cx="7560000" cy="5220000"/>
+          </a:xfrm>
+          <a:prstGeom prst="rect">
+            <a:avLst/>
+          </a:prstGeom>
+          <a:noFill/>
+        </p:spPr>
+        <p:txBody>
+          <a:bodyPr wrap="square">
+            <a:spAutoFit/>
+          </a:bodyPr>
+          <a:lstStyle/>
+          <a:p>
+            <a:pPr>
+              <a:spcAft>
+                <a:spcPts val="500"/>
+              </a:spcAft>
+              <a:defRPr sz="1600">
+                <a:solidFill>
+                  <a:srgbClr val="444444"/>
+                </a:solidFill>
+              </a:defRPr>
+            </a:pPr>
+            <a:r>
+              <a:t>Biến số                        Dữ liệu                       Ý nghĩa</a:t>
+            </a:r>
+          </a:p>
+          <a:p>
+            <a:pPr>
+              <a:spcAft>
+                <a:spcPts val="500"/>
+              </a:spcAft>
+              <a:defRPr sz="1600">
+                <a:solidFill>
+                  <a:srgbClr val="444444"/>
+                </a:solidFill>
+              </a:defRPr>
+            </a:pPr>
+            <a:r>
+              <a:t>─────────────────────────────────────────────────────────────────</a:t>
+            </a:r>
+          </a:p>
+          <a:p>
+            <a:pPr>
+              <a:spcAft>
+                <a:spcPts val="500"/>
+              </a:spcAft>
+              <a:defRPr sz="1600">
+                <a:solidFill>
+                  <a:srgbClr val="444444"/>
+                </a:solidFill>
+              </a:defRPr>
+            </a:pPr>
+            <a:r>
+              <a:t>Thu nhập              +10%/năm              Làm người mua muốn mua nhiều hơn</a:t>
+            </a:r>
+          </a:p>
+          <a:p>
+            <a:pPr>
+              <a:spcAft>
+                <a:spcPts val="500"/>
+              </a:spcAft>
+              <a:defRPr sz="1600">
+                <a:solidFill>
+                  <a:srgbClr val="444444"/>
+                </a:solidFill>
+              </a:defRPr>
+            </a:pPr>
+            <a:r>
+              <a:t>Thuế xe xăng         Tăng vọt              Làm xe xăng kém hấp dẫn</a:t>
+            </a:r>
+          </a:p>
+          <a:p>
+            <a:pPr>
+              <a:spcAft>
+                <a:spcPts val="500"/>
+              </a:spcAft>
+              <a:defRPr sz="1600">
+                <a:solidFill>
+                  <a:srgbClr val="444444"/>
+                </a:solidFill>
+              </a:defRPr>
+            </a:pPr>
+            <a:r>
+              <a:t>Trợ cấp EV           Trực tiếp              Kéo người mua về xe điện</a:t>
+            </a:r>
+          </a:p>
+          <a:p>
+            <a:pPr>
+              <a:spcAft>
+                <a:spcPts val="500"/>
+              </a:spcAft>
+              <a:defRPr sz="1600">
+                <a:solidFill>
+                  <a:srgbClr val="444444"/>
+                </a:solidFill>
+              </a:defRPr>
+            </a:pPr>
+            <a:r>
+              <a:t>Giá Lithium          Tăng                   Làm sản xuất đắt hơn</a:t>
+            </a:r>
+          </a:p>
+          <a:p>
+            <a:pPr>
+              <a:spcAft>
+                <a:spcPts val="500"/>
+              </a:spcAft>
+              <a:defRPr sz="1600">
+                <a:solidFill>
+                  <a:srgbClr val="444444"/>
+                </a:solidFill>
+              </a:defRPr>
+            </a:pPr>
+            <a:r>
+              <a:t>Công nghệ pin       Tiến bộ               Làm sản xuất rẻ hơn</a:t>
+            </a:r>
+          </a:p>
+          <a:p>
+            <a:pPr>
+              <a:spcAft>
+                <a:spcPts val="500"/>
+              </a:spcAft>
+              <a:defRPr sz="1600">
+                <a:solidFill>
+                  <a:srgbClr val="444444"/>
+                </a:solidFill>
+              </a:defRPr>
+            </a:pPr>
+            <a:r>
+              <a:t>EcoDrive            60% thị phần         Ai bán, bán bao nhiêu</a:t>
+            </a:r>
+          </a:p>
+          <a:p>
+            <a:pPr>
+              <a:spcAft>
+                <a:spcPts val="500"/>
+              </a:spcAft>
+              <a:defRPr sz="1600">
+                <a:solidFill>
+                  <a:srgbClr val="444444"/>
+                </a:solidFill>
+              </a:defRPr>
+            </a:pPr>
+            <a:r>
+              <a:t>Đối thủ mới           10+ hãng ngoại        Cạnh tranh khốc liệt hơn</a:t>
+            </a:r>
+          </a:p>
+          <a:p>
+            <a:pPr>
+              <a:spcAft>
+                <a:spcPts val="500"/>
+              </a:spcAft>
+              <a:defRPr sz="1600">
+                <a:solidFill>
+                  <a:srgbClr val="444444"/>
+                </a:solidFill>
+              </a:defRPr>
+            </a:pPr>
+            <a:r>
+              <a:t>Giá điện sạc        Xu hướng tăng         Chi phí đi kèm khi dùng EV</a:t>
+            </a:r>
+          </a:p>
+          <a:p>
+            <a:pPr>
+              <a:spcAft>
+                <a:spcPts val="500"/>
+              </a:spcAft>
+              <a:defRPr sz="1600">
+                <a:solidFill>
+                  <a:srgbClr val="444444"/>
+                </a:solidFill>
+              </a:defRPr>
+            </a:pPr>
+            <a:r>
+              <a:t>Chiến lược          R&amp;D + Quảng cáo    Giành khách bằng giá trị</a:t>
+            </a:r>
+          </a:p>
+        </p:txBody>
+      </p:sp>
+    </p:spTree>
+  </p:cSld>
+  <p:clrMapOvr>
+    <a:masterClrMapping/>
+  </p:clrMapOvr>
+</p:sld>
+</file>
+
+<file path=ppt/slides/slide4.xml><?xml version="1.0" encoding="utf-8"?>
 <p:sld xmlns:a="http://schemas.openxmlformats.org/drawingml/2006/main" xmlns:p="http://schemas.openxmlformats.org/presentationml/2006/main" xmlns:r="http://schemas.openxmlformats.org/officeDocument/2006/relationships">
   <p:cSld>
     <p:bg>
@@ -4575,8 +4798,8 @@
         </p:nvSpPr>
         <p:spPr>
           <a:xfrm>
-            <a:off x="720000" y="2520000"/>
-            <a:ext cx="7560000" cy="1080000"/>
+            <a:off x="720000" y="2340000"/>
+            <a:ext cx="7560000" cy="1440000"/>
           </a:xfrm>
           <a:prstGeom prst="rect">
             <a:avLst/>
@@ -4590,231 +4813,26 @@
           <a:lstStyle/>
           <a:p>
             <a:pPr algn="ctr">
-              <a:defRPr sz="3200" b="1">
+              <a:defRPr sz="3000" b="1">
                 <a:solidFill>
                   <a:srgbClr val="FFFFFF"/>
                 </a:solidFill>
               </a:defRPr>
             </a:pPr>
             <a:r>
-              <a:t>NHỮNG LỰC LƯỢNG ĐỊNH HÌNH THỊ TRƯỜNG</a:t>
-            </a:r>
-          </a:p>
-        </p:txBody>
-      </p:sp>
-    </p:spTree>
-  </p:cSld>
-  <p:clrMapOvr>
-    <a:masterClrMapping/>
-  </p:clrMapOvr>
-</p:sld>
-</file>
-
-<file path=ppt/slides/slide4.xml><?xml version="1.0" encoding="utf-8"?>
-<p:sld xmlns:a="http://schemas.openxmlformats.org/drawingml/2006/main" xmlns:p="http://schemas.openxmlformats.org/presentationml/2006/main" xmlns:r="http://schemas.openxmlformats.org/officeDocument/2006/relationships">
-  <p:cSld>
-    <p:spTree>
-      <p:nvGrpSpPr>
-        <p:cNvPr id="1" name=""/>
-        <p:cNvGrpSpPr/>
-        <p:nvPr/>
-      </p:nvGrpSpPr>
-      <p:grpSpPr/>
-      <p:sp>
-        <p:nvSpPr>
-          <p:cNvPr id="2" name="TextBox 1"/>
-          <p:cNvSpPr txBox="1"/>
-          <p:nvPr/>
-        </p:nvSpPr>
-        <p:spPr>
-          <a:xfrm>
-            <a:off x="540000" y="288000"/>
-            <a:ext cx="7920000" cy="792000"/>
-          </a:xfrm>
-          <a:prstGeom prst="rect">
-            <a:avLst/>
-          </a:prstGeom>
-          <a:noFill/>
-        </p:spPr>
-        <p:txBody>
-          <a:bodyPr wrap="square">
-            <a:spAutoFit/>
-          </a:bodyPr>
-          <a:lstStyle/>
-          <a:p>
-            <a:pPr>
-              <a:defRPr sz="2600" b="1">
-                <a:solidFill>
-                  <a:srgbClr val="1B1B2F"/>
-                </a:solidFill>
-              </a:defRPr>
-            </a:pPr>
-            <a:r>
-              <a:t>PHÍA CẦU: BA LỰC ĐẨY</a:t>
-            </a:r>
-          </a:p>
-        </p:txBody>
-      </p:sp>
-      <p:sp>
-        <p:nvSpPr>
-          <p:cNvPr id="3" name="TextBox 2"/>
-          <p:cNvSpPr txBox="1"/>
-          <p:nvPr/>
-        </p:nvSpPr>
-        <p:spPr>
-          <a:xfrm>
-            <a:off x="648000" y="1152000"/>
-            <a:ext cx="7560000" cy="5040000"/>
-          </a:xfrm>
-          <a:prstGeom prst="rect">
-            <a:avLst/>
-          </a:prstGeom>
-          <a:noFill/>
-        </p:spPr>
-        <p:txBody>
-          <a:bodyPr wrap="square">
-            <a:spAutoFit/>
-          </a:bodyPr>
-          <a:lstStyle/>
-          <a:p>
-            <a:pPr>
-              <a:spcAft>
-                <a:spcPts val="600"/>
-              </a:spcAft>
-              <a:defRPr sz="1700">
-                <a:solidFill>
-                  <a:srgbClr val="555555"/>
-                </a:solidFill>
-              </a:defRPr>
-            </a:pPr>
-            <a:r>
-              <a:t>1. Thu nhập tăng 10%/năm</a:t>
-            </a:r>
-          </a:p>
-          <a:p>
-            <a:pPr>
-              <a:spcAft>
-                <a:spcPts val="600"/>
-              </a:spcAft>
-              <a:defRPr sz="1700">
-                <a:solidFill>
-                  <a:srgbClr val="555555"/>
-                </a:solidFill>
-              </a:defRPr>
-            </a:pPr>
-            <a:r>
-              <a:t>   Xe điện trở thành biểu tượng lối sống thượng lưu</a:t>
-            </a:r>
-          </a:p>
-          <a:p>
-            <a:pPr>
-              <a:spcAft>
-                <a:spcPts val="600"/>
-              </a:spcAft>
-              <a:defRPr sz="1700">
-                <a:solidFill>
-                  <a:srgbClr val="555555"/>
-                </a:solidFill>
-              </a:defRPr>
-            </a:pPr>
-          </a:p>
-          <a:p>
-            <a:pPr>
-              <a:spcAft>
-                <a:spcPts val="600"/>
-              </a:spcAft>
-              <a:defRPr sz="1700">
-                <a:solidFill>
-                  <a:srgbClr val="555555"/>
-                </a:solidFill>
-              </a:defRPr>
-            </a:pPr>
-            <a:r>
-              <a:t>2. Trợ cấp trực tiếp cho người mua</a:t>
-            </a:r>
-          </a:p>
-          <a:p>
-            <a:pPr>
-              <a:spcAft>
-                <a:spcPts val="600"/>
-              </a:spcAft>
-              <a:defRPr sz="1700">
-                <a:solidFill>
-                  <a:srgbClr val="555555"/>
-                </a:solidFill>
-              </a:defRPr>
-            </a:pPr>
-            <a:r>
-              <a:t>   Giảm giá thực tế, tăng khả năng thanh toán</a:t>
-            </a:r>
-          </a:p>
-          <a:p>
-            <a:pPr>
-              <a:spcAft>
-                <a:spcPts val="600"/>
-              </a:spcAft>
-              <a:defRPr sz="1700">
-                <a:solidFill>
-                  <a:srgbClr val="555555"/>
-                </a:solidFill>
-              </a:defRPr>
-            </a:pPr>
-          </a:p>
-          <a:p>
-            <a:pPr>
-              <a:spcAft>
-                <a:spcPts val="600"/>
-              </a:spcAft>
-              <a:defRPr sz="1700">
-                <a:solidFill>
-                  <a:srgbClr val="555555"/>
-                </a:solidFill>
-              </a:defRPr>
-            </a:pPr>
-            <a:r>
-              <a:t>3. Thuế xe xăng tăng vọt</a:t>
-            </a:r>
-          </a:p>
-          <a:p>
-            <a:pPr>
-              <a:spcAft>
-                <a:spcPts val="600"/>
-              </a:spcAft>
-              <a:defRPr sz="1700">
-                <a:solidFill>
-                  <a:srgbClr val="555555"/>
-                </a:solidFill>
-              </a:defRPr>
-            </a:pPr>
-            <a:r>
-              <a:t>   Chi phí cơ hội của xe truyền thống cao hơn</a:t>
-            </a:r>
-          </a:p>
-          <a:p>
-            <a:pPr>
-              <a:spcAft>
-                <a:spcPts val="600"/>
-              </a:spcAft>
-              <a:defRPr sz="1700">
-                <a:solidFill>
-                  <a:srgbClr val="555555"/>
-                </a:solidFill>
-              </a:defRPr>
-            </a:pPr>
-          </a:p>
-          <a:p>
-            <a:pPr>
-              <a:spcAft>
-                <a:spcPts val="600"/>
-              </a:spcAft>
-              <a:defRPr sz="1700" b="1">
-                <a:solidFill>
-                  <a:srgbClr val="2D6A4F"/>
-                </a:solidFill>
-              </a:defRPr>
-            </a:pPr>
-            <a:r>
-              <a:t>→ Đường cầu dịch chuyển mạnh sang phải</a:t>
+              <a:t>BIẾN ĐỘNG THỊ TRƯỜNG</a:t>
+            </a:r>
+          </a:p>
+          <a:p>
+            <a:pPr algn="ctr">
+              <a:defRPr sz="1400">
+                <a:solidFill>
+                  <a:srgbClr val="CCCCCC"/>
+                </a:solidFill>
+              </a:defRPr>
+            </a:pPr>
+            <a:r>
+              <a:t>Trả lời câu hỏi 1</a:t>
             </a:r>
           </a:p>
         </p:txBody>
@@ -4845,8 +4863,8 @@
         </p:nvSpPr>
         <p:spPr>
           <a:xfrm>
-            <a:off x="540000" y="288000"/>
-            <a:ext cx="7920000" cy="792000"/>
+            <a:off x="540000" y="216000"/>
+            <a:ext cx="7920000" cy="720000"/>
           </a:xfrm>
           <a:prstGeom prst="rect">
             <a:avLst/>
@@ -4860,14 +4878,26 @@
           <a:lstStyle/>
           <a:p>
             <a:pPr>
-              <a:defRPr sz="2600" b="1">
+              <a:defRPr sz="2400" b="1">
                 <a:solidFill>
                   <a:srgbClr val="1B1B2F"/>
                 </a:solidFill>
               </a:defRPr>
             </a:pPr>
             <a:r>
-              <a:t>PHÍA CUNG: HAI LỰC NGƯỢC CHIỀU</a:t>
+              <a:t>CẦU TĂNG MẠNH + CUNG BỊ KÌM</a:t>
+            </a:r>
+          </a:p>
+          <a:p>
+            <a:pPr>
+              <a:defRPr sz="1200" i="1">
+                <a:solidFill>
+                  <a:srgbClr val="2D6A4F"/>
+                </a:solidFill>
+              </a:defRPr>
+            </a:pPr>
+            <a:r>
+              <a:t>Câu 1: Khi Cung và Cầu cùng dịch phải nhưng Lithium cũng tăng?</a:t>
             </a:r>
           </a:p>
         </p:txBody>
@@ -4880,8 +4910,8 @@
         </p:nvSpPr>
         <p:spPr>
           <a:xfrm>
-            <a:off x="648000" y="1152000"/>
-            <a:ext cx="7560000" cy="5040000"/>
+            <a:off x="648000" y="1080000"/>
+            <a:ext cx="7560000" cy="5220000"/>
           </a:xfrm>
           <a:prstGeom prst="rect">
             <a:avLst/>
@@ -4896,138 +4926,138 @@
           <a:p>
             <a:pPr>
               <a:spcAft>
-                <a:spcPts val="600"/>
-              </a:spcAft>
-              <a:defRPr sz="1700">
-                <a:solidFill>
-                  <a:srgbClr val="555555"/>
-                </a:solidFill>
-              </a:defRPr>
-            </a:pPr>
-            <a:r>
-              <a:t>Lực đẩy (tích cực):</a:t>
-            </a:r>
-          </a:p>
-          <a:p>
-            <a:pPr>
-              <a:spcAft>
-                <a:spcPts val="600"/>
-              </a:spcAft>
-              <a:defRPr sz="1700">
-                <a:solidFill>
-                  <a:srgbClr val="555555"/>
-                </a:solidFill>
-              </a:defRPr>
-            </a:pPr>
-            <a:r>
-              <a:t>   Công nghệ pin tiến bộ → giảm chi phí sản xuất bình quân</a:t>
-            </a:r>
-          </a:p>
-          <a:p>
-            <a:pPr>
-              <a:spcAft>
-                <a:spcPts val="600"/>
-              </a:spcAft>
-              <a:defRPr sz="1700">
-                <a:solidFill>
-                  <a:srgbClr val="555555"/>
-                </a:solidFill>
-              </a:defRPr>
-            </a:pPr>
-          </a:p>
-          <a:p>
-            <a:pPr>
-              <a:spcAft>
-                <a:spcPts val="600"/>
-              </a:spcAft>
-              <a:defRPr sz="1700">
-                <a:solidFill>
-                  <a:srgbClr val="555555"/>
-                </a:solidFill>
-              </a:defRPr>
-            </a:pPr>
-            <a:r>
-              <a:t>Lực kéo (tiêu cực):</a:t>
-            </a:r>
-          </a:p>
-          <a:p>
-            <a:pPr>
-              <a:spcAft>
-                <a:spcPts val="600"/>
-              </a:spcAft>
-              <a:defRPr sz="1700">
-                <a:solidFill>
-                  <a:srgbClr val="555555"/>
-                </a:solidFill>
-              </a:defRPr>
-            </a:pPr>
-            <a:r>
-              <a:t>   Đứt gãy chuỗi cung ứng Lithium toàn cầu</a:t>
-            </a:r>
-          </a:p>
-          <a:p>
-            <a:pPr>
-              <a:spcAft>
-                <a:spcPts val="600"/>
-              </a:spcAft>
-              <a:defRPr sz="1700">
-                <a:solidFill>
-                  <a:srgbClr val="555555"/>
-                </a:solidFill>
-              </a:defRPr>
-            </a:pPr>
-            <a:r>
-              <a:t>   → Chi phí biên tăng cao</a:t>
-            </a:r>
-          </a:p>
-          <a:p>
-            <a:pPr>
-              <a:spcAft>
-                <a:spcPts val="600"/>
-              </a:spcAft>
-              <a:defRPr sz="1700">
-                <a:solidFill>
-                  <a:srgbClr val="555555"/>
-                </a:solidFill>
-              </a:defRPr>
-            </a:pPr>
-            <a:r>
-              <a:t>   → Nhà sản xuất buộc phải lựa chọn:</a:t>
-            </a:r>
-          </a:p>
-          <a:p>
-            <a:pPr>
-              <a:spcAft>
-                <a:spcPts val="600"/>
-              </a:spcAft>
-              <a:defRPr sz="1700">
-                <a:solidFill>
-                  <a:srgbClr val="555555"/>
-                </a:solidFill>
-              </a:defRPr>
-            </a:pPr>
-            <a:r>
-              <a:t>      Hấp thụ chi phí hay chuyển sang người tiêu dùng?</a:t>
-            </a:r>
-          </a:p>
-          <a:p>
-            <a:pPr>
-              <a:spcAft>
-                <a:spcPts val="600"/>
-              </a:spcAft>
-              <a:defRPr sz="1700">
-                <a:solidFill>
-                  <a:srgbClr val="555555"/>
-                </a:solidFill>
-              </a:defRPr>
-            </a:pPr>
-          </a:p>
-          <a:p>
-            <a:pPr>
-              <a:spcAft>
-                <a:spcPts val="600"/>
-              </a:spcAft>
-              <a:defRPr sz="1700" b="1">
+                <a:spcPts val="500"/>
+              </a:spcAft>
+              <a:defRPr sz="1600">
+                <a:solidFill>
+                  <a:srgbClr val="444444"/>
+                </a:solidFill>
+              </a:defRPr>
+            </a:pPr>
+            <a:r>
+              <a:t>Phía Cầu – 3 lực đẩy sang phải:</a:t>
+            </a:r>
+          </a:p>
+          <a:p>
+            <a:pPr>
+              <a:spcAft>
+                <a:spcPts val="500"/>
+              </a:spcAft>
+              <a:defRPr sz="1600">
+                <a:solidFill>
+                  <a:srgbClr val="444444"/>
+                </a:solidFill>
+              </a:defRPr>
+            </a:pPr>
+            <a:r>
+              <a:t>   • Thu nhập +10%/năm → xã hội giàu hơn, mua nhiều hơn</a:t>
+            </a:r>
+          </a:p>
+          <a:p>
+            <a:pPr>
+              <a:spcAft>
+                <a:spcPts val="500"/>
+              </a:spcAft>
+              <a:defRPr sz="1600">
+                <a:solidFill>
+                  <a:srgbClr val="444444"/>
+                </a:solidFill>
+              </a:defRPr>
+            </a:pPr>
+            <a:r>
+              <a:t>   • Trợ cấp trực tiếp → giảm rào cản tài chính</a:t>
+            </a:r>
+          </a:p>
+          <a:p>
+            <a:pPr>
+              <a:spcAft>
+                <a:spcPts val="500"/>
+              </a:spcAft>
+              <a:defRPr sz="1600">
+                <a:solidFill>
+                  <a:srgbClr val="444444"/>
+                </a:solidFill>
+              </a:defRPr>
+            </a:pPr>
+            <a:r>
+              <a:t>   • Thuế xe xăng → hàng thay thế đắt, cầu EV tăng</a:t>
+            </a:r>
+          </a:p>
+          <a:p>
+            <a:pPr>
+              <a:spcAft>
+                <a:spcPts val="500"/>
+              </a:spcAft>
+              <a:defRPr sz="1600">
+                <a:solidFill>
+                  <a:srgbClr val="444444"/>
+                </a:solidFill>
+              </a:defRPr>
+            </a:pPr>
+          </a:p>
+          <a:p>
+            <a:pPr>
+              <a:spcAft>
+                <a:spcPts val="500"/>
+              </a:spcAft>
+              <a:defRPr sz="1600">
+                <a:solidFill>
+                  <a:srgbClr val="444444"/>
+                </a:solidFill>
+              </a:defRPr>
+            </a:pPr>
+            <a:r>
+              <a:t>Phía Cung – 2 lực ngược chiều:</a:t>
+            </a:r>
+          </a:p>
+          <a:p>
+            <a:pPr>
+              <a:spcAft>
+                <a:spcPts val="500"/>
+              </a:spcAft>
+              <a:defRPr sz="1600">
+                <a:solidFill>
+                  <a:srgbClr val="444444"/>
+                </a:solidFill>
+              </a:defRPr>
+            </a:pPr>
+            <a:r>
+              <a:t>   • Công nghệ pin ↑ → đẩy cung sang phải</a:t>
+            </a:r>
+          </a:p>
+          <a:p>
+            <a:pPr>
+              <a:spcAft>
+                <a:spcPts val="500"/>
+              </a:spcAft>
+              <a:defRPr sz="1600">
+                <a:solidFill>
+                  <a:srgbClr val="444444"/>
+                </a:solidFill>
+              </a:defRPr>
+            </a:pPr>
+            <a:r>
+              <a:t>   • Lithium ↑ → kéo cung ngược lại</a:t>
+            </a:r>
+          </a:p>
+          <a:p>
+            <a:pPr>
+              <a:spcAft>
+                <a:spcPts val="500"/>
+              </a:spcAft>
+              <a:defRPr sz="1600">
+                <a:solidFill>
+                  <a:srgbClr val="444444"/>
+                </a:solidFill>
+              </a:defRPr>
+            </a:pPr>
+          </a:p>
+          <a:p>
+            <a:pPr>
+              <a:spcAft>
+                <a:spcPts val="500"/>
+              </a:spcAft>
+              <a:defRPr sz="1600" b="1">
                 <a:solidFill>
                   <a:srgbClr val="2D6A4F"/>
                 </a:solidFill>
@@ -5065,8 +5095,8 @@
         </p:nvSpPr>
         <p:spPr>
           <a:xfrm>
-            <a:off x="540000" y="180000"/>
-            <a:ext cx="7920000" cy="648000"/>
+            <a:off x="540000" y="108000"/>
+            <a:ext cx="7920000" cy="720000"/>
           </a:xfrm>
           <a:prstGeom prst="rect">
             <a:avLst/>
@@ -5080,14 +5110,26 @@
           <a:lstStyle/>
           <a:p>
             <a:pPr>
-              <a:defRPr sz="2200" b="1">
+              <a:defRPr sz="2000" b="1">
                 <a:solidFill>
                   <a:srgbClr val="1B1B2F"/>
                 </a:solidFill>
               </a:defRPr>
             </a:pPr>
             <a:r>
-              <a:t>Kết quả: Cầu mạnh + Cung yếu → Giá tăng</a:t>
+              <a:t>KếT LUẬN CÂU 1</a:t>
+            </a:r>
+          </a:p>
+          <a:p>
+            <a:pPr>
+              <a:defRPr sz="1200" i="1">
+                <a:solidFill>
+                  <a:srgbClr val="2D6A4F"/>
+                </a:solidFill>
+              </a:defRPr>
+            </a:pPr>
+            <a:r>
+              <a:t>Áp lực lên giá bán cuối cùng là TĂNG vì Cầu bùng nổ trong khi Cung bị kìm hãm</a:t>
             </a:r>
           </a:p>
         </p:txBody>
@@ -5108,8 +5150,8 @@
         </p:blipFill>
         <p:spPr>
           <a:xfrm>
-            <a:off x="432000" y="1007999"/>
-            <a:ext cx="8100000" cy="5343648"/>
+            <a:off x="360000" y="1007999"/>
+            <a:ext cx="8280000" cy="5454882"/>
           </a:xfrm>
           <a:prstGeom prst="rect">
             <a:avLst/>
@@ -5150,8 +5192,8 @@
         </p:nvSpPr>
         <p:spPr>
           <a:xfrm>
-            <a:off x="720000" y="2520000"/>
-            <a:ext cx="7560000" cy="1080000"/>
+            <a:off x="720000" y="2340000"/>
+            <a:ext cx="7560000" cy="1440000"/>
           </a:xfrm>
           <a:prstGeom prst="rect">
             <a:avLst/>
@@ -5165,14 +5207,26 @@
           <a:lstStyle/>
           <a:p>
             <a:pPr algn="ctr">
-              <a:defRPr sz="3200" b="1">
+              <a:defRPr sz="3000" b="1">
                 <a:solidFill>
                   <a:srgbClr val="FFFFFF"/>
                 </a:solidFill>
               </a:defRPr>
             </a:pPr>
             <a:r>
-              <a:t>MỐI LIÊN KẾT ẨN TRONG HỆ THỐNG</a:t>
+              <a:t>HÀNG THAY THẾ &amp; HÀNG BỔ SUNG</a:t>
+            </a:r>
+          </a:p>
+          <a:p>
+            <a:pPr algn="ctr">
+              <a:defRPr sz="1400">
+                <a:solidFill>
+                  <a:srgbClr val="CCCCCC"/>
+                </a:solidFill>
+              </a:defRPr>
+            </a:pPr>
+            <a:r>
+              <a:t>Trả lời câu hỏi 2</a:t>
             </a:r>
           </a:p>
         </p:txBody>
@@ -5203,8 +5257,8 @@
         </p:nvSpPr>
         <p:spPr>
           <a:xfrm>
-            <a:off x="540000" y="288000"/>
-            <a:ext cx="7920000" cy="792000"/>
+            <a:off x="540000" y="216000"/>
+            <a:ext cx="7920000" cy="720000"/>
           </a:xfrm>
           <a:prstGeom prst="rect">
             <a:avLst/>
@@ -5218,14 +5272,26 @@
           <a:lstStyle/>
           <a:p>
             <a:pPr>
-              <a:defRPr sz="2600" b="1">
+              <a:defRPr sz="2400" b="1">
                 <a:solidFill>
                   <a:srgbClr val="1B1B2F"/>
                 </a:solidFill>
               </a:defRPr>
             </a:pPr>
             <a:r>
-              <a:t>HÀNG HÓA KHÔNG TỒN TẠI ĐƠN LẺ</a:t>
+              <a:t>MỐI QUAN HỆ GIỮa CÁC HÀNG HÓA</a:t>
+            </a:r>
+          </a:p>
+          <a:p>
+            <a:pPr>
+              <a:defRPr sz="1200" i="1">
+                <a:solidFill>
+                  <a:srgbClr val="2D6A4F"/>
+                </a:solidFill>
+              </a:defRPr>
+            </a:pPr>
+            <a:r>
+              <a:t>Câu 2: Nếu giá điện sạc tăng vọt, lợi ích cận biên bị ảnh hưởng ra sao?</a:t>
             </a:r>
           </a:p>
         </p:txBody>
@@ -5238,8 +5304,8 @@
         </p:nvSpPr>
         <p:spPr>
           <a:xfrm>
-            <a:off x="648000" y="1152000"/>
-            <a:ext cx="7560000" cy="5040000"/>
+            <a:off x="648000" y="1080000"/>
+            <a:ext cx="7560000" cy="5220000"/>
           </a:xfrm>
           <a:prstGeom prst="rect">
             <a:avLst/>
@@ -5254,160 +5320,145 @@
           <a:p>
             <a:pPr>
               <a:spcAft>
-                <a:spcPts val="600"/>
-              </a:spcAft>
-              <a:defRPr sz="1700">
-                <a:solidFill>
-                  <a:srgbClr val="555555"/>
-                </a:solidFill>
-              </a:defRPr>
-            </a:pPr>
-            <a:r>
-              <a:t>Xe xăng và Xe điện – hàng thay thế:</a:t>
-            </a:r>
-          </a:p>
-          <a:p>
-            <a:pPr>
-              <a:spcAft>
-                <a:spcPts val="600"/>
-              </a:spcAft>
-              <a:defRPr sz="1700">
-                <a:solidFill>
-                  <a:srgbClr val="555555"/>
-                </a:solidFill>
-              </a:defRPr>
-            </a:pPr>
-            <a:r>
-              <a:t>   Thuế xe xăng ↑ → Người dùng chuyển sang xe điện</a:t>
-            </a:r>
-          </a:p>
-          <a:p>
-            <a:pPr>
-              <a:spcAft>
-                <a:spcPts val="600"/>
-              </a:spcAft>
-              <a:defRPr sz="1700">
-                <a:solidFill>
-                  <a:srgbClr val="555555"/>
-                </a:solidFill>
-              </a:defRPr>
-            </a:pPr>
-            <a:r>
-              <a:t>   Cầu xe điện tăng</a:t>
-            </a:r>
-          </a:p>
-          <a:p>
-            <a:pPr>
-              <a:spcAft>
-                <a:spcPts val="600"/>
-              </a:spcAft>
-              <a:defRPr sz="1700">
-                <a:solidFill>
-                  <a:srgbClr val="555555"/>
-                </a:solidFill>
-              </a:defRPr>
-            </a:pPr>
-          </a:p>
-          <a:p>
-            <a:pPr>
-              <a:spcAft>
-                <a:spcPts val="600"/>
-              </a:spcAft>
-              <a:defRPr sz="1700">
-                <a:solidFill>
-                  <a:srgbClr val="555555"/>
-                </a:solidFill>
-              </a:defRPr>
-            </a:pPr>
-            <a:r>
-              <a:t>Xe điện và Điện sạc – hàng bổ sung:</a:t>
-            </a:r>
-          </a:p>
-          <a:p>
-            <a:pPr>
-              <a:spcAft>
-                <a:spcPts val="600"/>
-              </a:spcAft>
-              <a:defRPr sz="1700">
-                <a:solidFill>
-                  <a:srgbClr val="555555"/>
-                </a:solidFill>
-              </a:defRPr>
-            </a:pPr>
-            <a:r>
-              <a:t>   Giá điện sạc ↑ → Chi phí vận hành tăng</a:t>
-            </a:r>
-          </a:p>
-          <a:p>
-            <a:pPr>
-              <a:spcAft>
-                <a:spcPts val="600"/>
-              </a:spcAft>
-              <a:defRPr sz="1700">
-                <a:solidFill>
-                  <a:srgbClr val="555555"/>
-                </a:solidFill>
-              </a:defRPr>
-            </a:pPr>
-            <a:r>
-              <a:t>   Lợi ích cận biên của mỗi km giảm</a:t>
-            </a:r>
-          </a:p>
-          <a:p>
-            <a:pPr>
-              <a:spcAft>
-                <a:spcPts val="600"/>
-              </a:spcAft>
-              <a:defRPr sz="1700">
-                <a:solidFill>
-                  <a:srgbClr val="555555"/>
-                </a:solidFill>
-              </a:defRPr>
-            </a:pPr>
-            <a:r>
-              <a:t>   Sức hấp dẫn kinh tế của xe điện bị xoi mòn</a:t>
-            </a:r>
-          </a:p>
-          <a:p>
-            <a:pPr>
-              <a:spcAft>
-                <a:spcPts val="600"/>
-              </a:spcAft>
-              <a:defRPr sz="1700">
-                <a:solidFill>
-                  <a:srgbClr val="555555"/>
-                </a:solidFill>
-              </a:defRPr>
-            </a:pPr>
-          </a:p>
-          <a:p>
-            <a:pPr>
-              <a:spcAft>
-                <a:spcPts val="600"/>
-              </a:spcAft>
-              <a:defRPr sz="1700" b="1">
+                <a:spcPts val="500"/>
+              </a:spcAft>
+              <a:defRPr sz="1600">
+                <a:solidFill>
+                  <a:srgbClr val="444444"/>
+                </a:solidFill>
+              </a:defRPr>
+            </a:pPr>
+            <a:r>
+              <a:t>Xe xăng ↔ Xe điện (Hàng thay thế):</a:t>
+            </a:r>
+          </a:p>
+          <a:p>
+            <a:pPr>
+              <a:spcAft>
+                <a:spcPts val="500"/>
+              </a:spcAft>
+              <a:defRPr sz="1600">
+                <a:solidFill>
+                  <a:srgbClr val="444444"/>
+                </a:solidFill>
+              </a:defRPr>
+            </a:pPr>
+            <a:r>
+              <a:t>   Thuế xe xăng ↑ → Giá xe xăng ↑ → Cầu EV ↑</a:t>
+            </a:r>
+          </a:p>
+          <a:p>
+            <a:pPr>
+              <a:spcAft>
+                <a:spcPts val="500"/>
+              </a:spcAft>
+              <a:defRPr sz="1600">
+                <a:solidFill>
+                  <a:srgbClr val="444444"/>
+                </a:solidFill>
+              </a:defRPr>
+            </a:pPr>
+            <a:r>
+              <a:t>   (Chính sách hoạt động đúng như kỳ vọng)</a:t>
+            </a:r>
+          </a:p>
+          <a:p>
+            <a:pPr>
+              <a:spcAft>
+                <a:spcPts val="500"/>
+              </a:spcAft>
+              <a:defRPr sz="1600">
+                <a:solidFill>
+                  <a:srgbClr val="444444"/>
+                </a:solidFill>
+              </a:defRPr>
+            </a:pPr>
+          </a:p>
+          <a:p>
+            <a:pPr>
+              <a:spcAft>
+                <a:spcPts val="500"/>
+              </a:spcAft>
+              <a:defRPr sz="1600">
+                <a:solidFill>
+                  <a:srgbClr val="444444"/>
+                </a:solidFill>
+              </a:defRPr>
+            </a:pPr>
+            <a:r>
+              <a:t>Xe điện + Điện sạc (Hàng bổ sung):</a:t>
+            </a:r>
+          </a:p>
+          <a:p>
+            <a:pPr>
+              <a:spcAft>
+                <a:spcPts val="500"/>
+              </a:spcAft>
+              <a:defRPr sz="1600">
+                <a:solidFill>
+                  <a:srgbClr val="444444"/>
+                </a:solidFill>
+              </a:defRPr>
+            </a:pPr>
+            <a:r>
+              <a:t>   Giá điện sạc ↑ → Chi phí vận hành ↑</a:t>
+            </a:r>
+          </a:p>
+          <a:p>
+            <a:pPr>
+              <a:spcAft>
+                <a:spcPts val="500"/>
+              </a:spcAft>
+              <a:defRPr sz="1600">
+                <a:solidFill>
+                  <a:srgbClr val="444444"/>
+                </a:solidFill>
+              </a:defRPr>
+            </a:pPr>
+            <a:r>
+              <a:t>   Lợi ích cận biên mỗi km giảm</a:t>
+            </a:r>
+          </a:p>
+          <a:p>
+            <a:pPr>
+              <a:spcAft>
+                <a:spcPts val="500"/>
+              </a:spcAft>
+              <a:defRPr sz="1600">
+                <a:solidFill>
+                  <a:srgbClr val="444444"/>
+                </a:solidFill>
+              </a:defRPr>
+            </a:pPr>
+            <a:r>
+              <a:t>   Ưu thế kinh tế của EV bị xoi mòn</a:t>
+            </a:r>
+          </a:p>
+          <a:p>
+            <a:pPr>
+              <a:spcAft>
+                <a:spcPts val="500"/>
+              </a:spcAft>
+              <a:defRPr sz="1600">
+                <a:solidFill>
+                  <a:srgbClr val="444444"/>
+                </a:solidFill>
+              </a:defRPr>
+            </a:pPr>
+          </a:p>
+          <a:p>
+            <a:pPr>
+              <a:spcAft>
+                <a:spcPts val="500"/>
+              </a:spcAft>
+              <a:defRPr sz="1600" b="1">
                 <a:solidFill>
                   <a:srgbClr val="2D6A4F"/>
                 </a:solidFill>
               </a:defRPr>
             </a:pPr>
             <a:r>
-              <a:t>→ Chính sách thành công hay thất bại phụ thuộc vào</a:t>
-            </a:r>
-          </a:p>
-          <a:p>
-            <a:pPr>
-              <a:spcAft>
-                <a:spcPts val="600"/>
-              </a:spcAft>
-              <a:defRPr sz="1700">
-                <a:solidFill>
-                  <a:srgbClr val="555555"/>
-                </a:solidFill>
-              </a:defRPr>
-            </a:pPr>
-            <a:r>
-              <a:t>   cả hệ thống hàng hóa liên quan</a:t>
+              <a:t>→ Sự ưu tiên của NTD đối với xe điện có thể bị lung lay</a:t>
             </a:r>
           </a:p>
         </p:txBody>
@@ -5438,8 +5489,8 @@
         </p:nvSpPr>
         <p:spPr>
           <a:xfrm>
-            <a:off x="540000" y="180000"/>
-            <a:ext cx="7920000" cy="648000"/>
+            <a:off x="540000" y="108000"/>
+            <a:ext cx="7920000" cy="720000"/>
           </a:xfrm>
           <a:prstGeom prst="rect">
             <a:avLst/>
@@ -5453,14 +5504,26 @@
           <a:lstStyle/>
           <a:p>
             <a:pPr>
-              <a:defRPr sz="2200" b="1">
+              <a:defRPr sz="2000" b="1">
                 <a:solidFill>
                   <a:srgbClr val="1B1B2F"/>
                 </a:solidFill>
               </a:defRPr>
             </a:pPr>
             <a:r>
-              <a:t>Tác động của hàng thay thế và bổ sung</a:t>
+              <a:t>KếT LUẬN CÂU 2</a:t>
+            </a:r>
+          </a:p>
+          <a:p>
+            <a:pPr>
+              <a:defRPr sz="1200" i="1">
+                <a:solidFill>
+                  <a:srgbClr val="2D6A4F"/>
+                </a:solidFill>
+              </a:defRPr>
+            </a:pPr>
+            <a:r>
+              <a:t>Giá hàng bổ sung tăng → Lợi ích cận biên giảm → CS chỉ hiệu quả khi kiểm soát cả hệ thống</a:t>
             </a:r>
           </a:p>
         </p:txBody>
@@ -5481,8 +5544,8 @@
         </p:blipFill>
         <p:spPr>
           <a:xfrm>
-            <a:off x="432000" y="1007999"/>
-            <a:ext cx="8100000" cy="3242980"/>
+            <a:off x="360000" y="1007999"/>
+            <a:ext cx="8280000" cy="3223666"/>
           </a:xfrm>
           <a:prstGeom prst="rect">
             <a:avLst/>

</xml_diff>

<commit_message>
vault backup: 2026-05-09 18:43:07
</commit_message>
<xml_diff>
--- a/01_Courses/01_Active/00_BSKT/00_Kinh Te Vi Mo/07_AI-Workspace/Outputs/Xe-dien-Alpha-Trinh-bay.pptx
+++ b/01_Courses/01_Active/00_BSKT/00_Kinh Te Vi Mo/07_AI-Workspace/Outputs/Xe-dien-Alpha-Trinh-bay.pptx
@@ -3547,7 +3547,7 @@
         <p:spPr>
           <a:xfrm>
             <a:off x="360000" y="1007999"/>
-            <a:ext cx="8280000" cy="5449937"/>
+            <a:ext cx="8280000" cy="5447368"/>
           </a:xfrm>
           <a:prstGeom prst="rect">
             <a:avLst/>
@@ -4609,7 +4609,7 @@
               </a:defRPr>
             </a:pPr>
             <a:r>
-              <a:t>Biến số                        Dữ liệu                       Ý nghĩa</a:t>
+              <a:t>Biến số                        Dữ liệu                       Loại biến</a:t>
             </a:r>
           </a:p>
           <a:p>
@@ -4639,127 +4639,127 @@
               </a:defRPr>
             </a:pPr>
             <a:r>
-              <a:t>Thu nhập              +10%/năm              Làm người mua muốn mua nhiều hơn</a:t>
-            </a:r>
-          </a:p>
-          <a:p>
-            <a:pPr>
-              <a:spcAft>
-                <a:spcPts val="500"/>
-              </a:spcAft>
-              <a:defRPr sz="1600">
-                <a:solidFill>
-                  <a:srgbClr val="444444"/>
-                </a:solidFill>
-              </a:defRPr>
-            </a:pPr>
-            <a:r>
-              <a:t>Thuế xe xăng         Tăng vọt              Làm xe xăng kém hấp dẫn</a:t>
-            </a:r>
-          </a:p>
-          <a:p>
-            <a:pPr>
-              <a:spcAft>
-                <a:spcPts val="500"/>
-              </a:spcAft>
-              <a:defRPr sz="1600">
-                <a:solidFill>
-                  <a:srgbClr val="444444"/>
-                </a:solidFill>
-              </a:defRPr>
-            </a:pPr>
-            <a:r>
-              <a:t>Trợ cấp EV           Trực tiếp              Kéo người mua về xe điện</a:t>
-            </a:r>
-          </a:p>
-          <a:p>
-            <a:pPr>
-              <a:spcAft>
-                <a:spcPts val="500"/>
-              </a:spcAft>
-              <a:defRPr sz="1600">
-                <a:solidFill>
-                  <a:srgbClr val="444444"/>
-                </a:solidFill>
-              </a:defRPr>
-            </a:pPr>
-            <a:r>
-              <a:t>Giá Lithium          Tăng                   Làm sản xuất đắt hơn</a:t>
-            </a:r>
-          </a:p>
-          <a:p>
-            <a:pPr>
-              <a:spcAft>
-                <a:spcPts val="500"/>
-              </a:spcAft>
-              <a:defRPr sz="1600">
-                <a:solidFill>
-                  <a:srgbClr val="444444"/>
-                </a:solidFill>
-              </a:defRPr>
-            </a:pPr>
-            <a:r>
-              <a:t>Công nghệ pin       Tiến bộ               Làm sản xuất rẻ hơn</a:t>
-            </a:r>
-          </a:p>
-          <a:p>
-            <a:pPr>
-              <a:spcAft>
-                <a:spcPts val="500"/>
-              </a:spcAft>
-              <a:defRPr sz="1600">
-                <a:solidFill>
-                  <a:srgbClr val="444444"/>
-                </a:solidFill>
-              </a:defRPr>
-            </a:pPr>
-            <a:r>
-              <a:t>EcoDrive            60% thị phần         Ai bán, bán bao nhiêu</a:t>
-            </a:r>
-          </a:p>
-          <a:p>
-            <a:pPr>
-              <a:spcAft>
-                <a:spcPts val="500"/>
-              </a:spcAft>
-              <a:defRPr sz="1600">
-                <a:solidFill>
-                  <a:srgbClr val="444444"/>
-                </a:solidFill>
-              </a:defRPr>
-            </a:pPr>
-            <a:r>
-              <a:t>Đối thủ mới           10+ hãng ngoại        Cạnh tranh khốc liệt hơn</a:t>
-            </a:r>
-          </a:p>
-          <a:p>
-            <a:pPr>
-              <a:spcAft>
-                <a:spcPts val="500"/>
-              </a:spcAft>
-              <a:defRPr sz="1600">
-                <a:solidFill>
-                  <a:srgbClr val="444444"/>
-                </a:solidFill>
-              </a:defRPr>
-            </a:pPr>
-            <a:r>
-              <a:t>Giá điện sạc        Xu hướng tăng         Chi phí đi kèm khi dùng EV</a:t>
-            </a:r>
-          </a:p>
-          <a:p>
-            <a:pPr>
-              <a:spcAft>
-                <a:spcPts val="500"/>
-              </a:spcAft>
-              <a:defRPr sz="1600">
-                <a:solidFill>
-                  <a:srgbClr val="444444"/>
-                </a:solidFill>
-              </a:defRPr>
-            </a:pPr>
-            <a:r>
-              <a:t>Chiến lược          R&amp;D + Quảng cáo    Giành khách bằng giá trị</a:t>
+              <a:t>Thu nhập              +10%/năm              Ngoại sinh – tác động cầu</a:t>
+            </a:r>
+          </a:p>
+          <a:p>
+            <a:pPr>
+              <a:spcAft>
+                <a:spcPts val="500"/>
+              </a:spcAft>
+              <a:defRPr sz="1600">
+                <a:solidFill>
+                  <a:srgbClr val="444444"/>
+                </a:solidFill>
+              </a:defRPr>
+            </a:pPr>
+            <a:r>
+              <a:t>Thuế xe xăng         Tăng vọt              Ngoại sinh – hàng thay thế</a:t>
+            </a:r>
+          </a:p>
+          <a:p>
+            <a:pPr>
+              <a:spcAft>
+                <a:spcPts val="500"/>
+              </a:spcAft>
+              <a:defRPr sz="1600">
+                <a:solidFill>
+                  <a:srgbClr val="444444"/>
+                </a:solidFill>
+              </a:defRPr>
+            </a:pPr>
+            <a:r>
+              <a:t>Trợ cấp EV           Trực tiếp              Ngoại sinh – dịch chuyển cầu</a:t>
+            </a:r>
+          </a:p>
+          <a:p>
+            <a:pPr>
+              <a:spcAft>
+                <a:spcPts val="500"/>
+              </a:spcAft>
+              <a:defRPr sz="1600">
+                <a:solidFill>
+                  <a:srgbClr val="444444"/>
+                </a:solidFill>
+              </a:defRPr>
+            </a:pPr>
+            <a:r>
+              <a:t>Giá Lithium          Tăng                   Ngoại sinh – tác động cung</a:t>
+            </a:r>
+          </a:p>
+          <a:p>
+            <a:pPr>
+              <a:spcAft>
+                <a:spcPts val="500"/>
+              </a:spcAft>
+              <a:defRPr sz="1600">
+                <a:solidFill>
+                  <a:srgbClr val="444444"/>
+                </a:solidFill>
+              </a:defRPr>
+            </a:pPr>
+            <a:r>
+              <a:t>Công nghệ pin       Tiến bộ               Ngoại sinh – tác động cung</a:t>
+            </a:r>
+          </a:p>
+          <a:p>
+            <a:pPr>
+              <a:spcAft>
+                <a:spcPts val="500"/>
+              </a:spcAft>
+              <a:defRPr sz="1600">
+                <a:solidFill>
+                  <a:srgbClr val="444444"/>
+                </a:solidFill>
+              </a:defRPr>
+            </a:pPr>
+            <a:r>
+              <a:t>EcoDrive            60% thị phần         Cấu trúc thị trường</a:t>
+            </a:r>
+          </a:p>
+          <a:p>
+            <a:pPr>
+              <a:spcAft>
+                <a:spcPts val="500"/>
+              </a:spcAft>
+              <a:defRPr sz="1600">
+                <a:solidFill>
+                  <a:srgbClr val="444444"/>
+                </a:solidFill>
+              </a:defRPr>
+            </a:pPr>
+            <a:r>
+              <a:t>Đối thủ mới           10+ hãng ngoại        Cấu trúc thị trường</a:t>
+            </a:r>
+          </a:p>
+          <a:p>
+            <a:pPr>
+              <a:spcAft>
+                <a:spcPts val="500"/>
+              </a:spcAft>
+              <a:defRPr sz="1600">
+                <a:solidFill>
+                  <a:srgbClr val="444444"/>
+                </a:solidFill>
+              </a:defRPr>
+            </a:pPr>
+            <a:r>
+              <a:t>Giá điện sạc        Xu hướng tăng         Hàng hóa bổ sung</a:t>
+            </a:r>
+          </a:p>
+          <a:p>
+            <a:pPr>
+              <a:spcAft>
+                <a:spcPts val="500"/>
+              </a:spcAft>
+              <a:defRPr sz="1600">
+                <a:solidFill>
+                  <a:srgbClr val="444444"/>
+                </a:solidFill>
+              </a:defRPr>
+            </a:pPr>
+            <a:r>
+              <a:t>Chiến lược          R&amp;D + Quảng cáo    Cạnh tranh phi giá</a:t>
             </a:r>
           </a:p>
         </p:txBody>
@@ -5416,7 +5416,7 @@
               </a:defRPr>
             </a:pPr>
             <a:r>
-              <a:t>   Lợi ích cận biên mỗi km giảm</a:t>
+              <a:t>   Lợi ích cận biên (MU) mỗi km giảm</a:t>
             </a:r>
           </a:p>
           <a:p>

</xml_diff>